<commit_message>
Operator guide v2 — 24 slides: 6 annotated action GIFs (click rings + keycaps), flag-queue deep dive (card anatomy, 3 card families, resolution guide, gate panel), processing-status error explained (stale 2026-07-31 run status), real exported-workbook preview
Co-Authored-By: Claude Fable 5 <noreply@anthropic.com>
</commit_message>
<xml_diff>
--- a/docs/Operator_Guide_2026-08-18.pptx
+++ b/docs/Operator_Guide_2026-08-18.pptx
@@ -21,6 +21,14 @@
     <p:sldId id="269" r:id="rId20"/>
     <p:sldId id="270" r:id="rId21"/>
     <p:sldId id="271" r:id="rId22"/>
+    <p:sldId id="272" r:id="rId23"/>
+    <p:sldId id="273" r:id="rId24"/>
+    <p:sldId id="274" r:id="rId25"/>
+    <p:sldId id="275" r:id="rId26"/>
+    <p:sldId id="276" r:id="rId27"/>
+    <p:sldId id="277" r:id="rId28"/>
+    <p:sldId id="278" r:id="rId29"/>
+    <p:sldId id="279" r:id="rId30"/>
   </p:sldIdLst>
   <p:sldSz cx="12191695" cy="6858000" type="screen4x3"/>
   <p:notesSz cx="6858000" cy="9144000"/>
@@ -3169,7 +3177,7 @@
                 </a:solidFill>
                 <a:latin typeface="Segoe UI"/>
               </a:rPr>
-              <a:t>AI detection and tracking, trajectory-based turn classification, and built-in QA — running entirely on your machine.</a:t>
+              <a:t>AI detection and tracking, trajectory-based turn classification, and built-in QA — running entirely on your machine. Slides marked ▶ carry animated walkthroughs (they play in slideshow mode).</a:t>
             </a:r>
           </a:p>
         </p:txBody>
@@ -3265,7 +3273,7 @@
                 </a:solidFill>
                 <a:latin typeface="Segoe UI"/>
               </a:rPr>
-              <a:t>STEP 5C · CALIBRATION</a:t>
+              <a:t>STEP 5A · ▶ IN MOTION</a:t>
             </a:r>
           </a:p>
           <a:p>
@@ -3281,7 +3289,7 @@
                 </a:solidFill>
                 <a:latin typeface="Segoe UI"/>
               </a:rPr>
-              <a:t>Road paths — then save</a:t>
+              <a:t>Open the editor, light the layers, scrub</a:t>
             </a:r>
           </a:p>
         </p:txBody>
@@ -3320,7 +3328,7 @@
                 </a:solidFill>
                 <a:latin typeface="Segoe UI"/>
               </a:rPr>
-              <a:t>The observed geometry</a:t>
+              <a:t>The editor tour</a:t>
             </a:r>
           </a:p>
           <a:p>
@@ -3336,7 +3344,7 @@
                 </a:solidFill>
                 <a:latin typeface="Segoe UI"/>
               </a:rPr>
-              <a:t>•  Road paths are the machine-derived center-lines from real observed journeys (10 on this camera) — review them against the video.</a:t>
+              <a:t>•  Recalibrate opens the editor on the calibration frame.</a:t>
             </a:r>
           </a:p>
           <a:p>
@@ -3352,7 +3360,7 @@
                 </a:solidFill>
                 <a:latin typeface="Segoe UI"/>
               </a:rPr>
-              <a:t>•  A missing path for a real movement is worth fixing: draw it, or re-run auto-calibration on a busier stretch of video.</a:t>
+              <a:t>•  The layers panel lights Legs / Paths / Channels overlays per approach — or all at once.</a:t>
             </a:r>
           </a:p>
           <a:p>
@@ -3368,30 +3376,14 @@
                 </a:solidFill>
                 <a:latin typeface="Segoe UI"/>
               </a:rPr>
-              <a:t>•  When the footer says all legs are placed, click Save calibration — nothing persists until you do.</a:t>
-            </a:r>
-          </a:p>
-          <a:p>
-            <a:pPr algn="l">
-              <a:spcAft>
-                <a:spcPts val="600"/>
-              </a:spcAft>
-            </a:pPr>
-            <a:r>
-              <a:rPr sz="1250" b="1">
-                <a:solidFill>
-                  <a:srgbClr val="B45309"/>
-                </a:solidFill>
-                <a:latin typeface="Segoe UI"/>
-              </a:rPr>
-              <a:t>⚠  Leaving without saving discards edits — deliberate exits are safe, accidental ones lose work.</a:t>
+              <a:t>•  Drag the timeline scrubber to any wall-clock moment; the frame refreshes — judge geometry against BUSY video, not an empty midnight frame.</a:t>
             </a:r>
           </a:p>
         </p:txBody>
       </p:sp>
       <p:pic>
         <p:nvPicPr>
-          <p:cNvPr id="4" name="Picture 3" descr="guide_08_calibration_paths.png"/>
+          <p:cNvPr id="4" name="Picture 3" descr="gif_03_calibration.gif"/>
           <p:cNvPicPr>
             <a:picLocks noChangeAspect="1"/>
           </p:cNvPicPr>
@@ -3406,7 +3398,7 @@
         <p:spPr>
           <a:xfrm>
             <a:off x="4617720" y="1481328"/>
-            <a:ext cx="7406640" cy="4166235"/>
+            <a:ext cx="7406640" cy="4167918"/>
           </a:xfrm>
           <a:prstGeom prst="rect">
             <a:avLst/>
@@ -3426,7 +3418,7 @@
         </p:nvSpPr>
         <p:spPr>
           <a:xfrm>
-            <a:off x="4617720" y="5715000"/>
+            <a:off x="4617720" y="5806440"/>
             <a:ext cx="7406640" cy="365760"/>
           </a:xfrm>
           <a:prstGeom prst="rect">
@@ -3452,7 +3444,7 @@
                 </a:solidFill>
                 <a:latin typeface="Segoe UI"/>
               </a:rPr>
-              <a:t>Derived road paths for every approach, ready to save.</a:t>
+              <a:t>▶ Recalibrate → overlays on → scrubbed to 08:00.</a:t>
             </a:r>
           </a:p>
         </p:txBody>
@@ -3509,7 +3501,7 @@
                 </a:solidFill>
                 <a:latin typeface="Segoe UI"/>
               </a:rPr>
-              <a:t>STEP 6 · TRIMS</a:t>
+              <a:t>STEP 5B · CALIBRATION</a:t>
             </a:r>
           </a:p>
           <a:p>
@@ -3525,7 +3517,7 @@
                 </a:solidFill>
                 <a:latin typeface="Segoe UI"/>
               </a:rPr>
-              <a:t>Choose the windows to count</a:t>
+              <a:t>Channels — sketch how traffic moves</a:t>
             </a:r>
           </a:p>
         </p:txBody>
@@ -3564,7 +3556,7 @@
                 </a:solidFill>
                 <a:latin typeface="Segoe UI"/>
               </a:rPr>
-              <a:t>Wall-clock windows</a:t>
+              <a:t>Guidelines, not fences</a:t>
             </a:r>
           </a:p>
           <a:p>
@@ -3580,7 +3572,7 @@
                 </a:solidFill>
                 <a:latin typeface="Segoe UI"/>
               </a:rPr>
-              <a:t>•  Each trim is a HH:MM:SS window processed across ALL cameras on the card — classic peak periods here: 07–09, 11–13, 16–18.</a:t>
+              <a:t>•  A channel is a movement's corridor: click entry → bend → exit; ends snap to the nearest leg.</a:t>
             </a:r>
           </a:p>
           <a:p>
@@ -3596,7 +3588,7 @@
                 </a:solidFill>
                 <a:latin typeface="Segoe UI"/>
               </a:rPr>
-              <a:t>•  Coverage tells you whether the uploaded footage actually spans the window (“Fully covered”).</a:t>
+              <a:t>•  Draw THROUGHS too, not just turns.</a:t>
             </a:r>
           </a:p>
           <a:p>
@@ -3612,7 +3604,7 @@
                 </a:solidFill>
                 <a:latin typeface="Segoe UI"/>
               </a:rPr>
-              <a:t>•  Per-camera coverage below shows each camera's true recording span as a cross-check.</a:t>
+              <a:t>•  Channels are layout guidance — cars share mouths and drift across lanes; the trajectory over time decides the turn.</a:t>
             </a:r>
           </a:p>
           <a:p>
@@ -3628,14 +3620,14 @@
                 </a:solidFill>
                 <a:latin typeface="Segoe UI"/>
               </a:rPr>
-              <a:t>•  Fewer, tighter trims = faster processing; a full-day card is an overnight run.</a:t>
+              <a:t>•  16 channels = all movements incl. U-turns at a 4-leg intersection.</a:t>
             </a:r>
           </a:p>
         </p:txBody>
       </p:sp>
       <p:pic>
         <p:nvPicPr>
-          <p:cNvPr id="4" name="Picture 3" descr="guide_09_clip_trims.png"/>
+          <p:cNvPr id="4" name="Picture 3" descr="guide_07_calibration_channels.png"/>
           <p:cNvPicPr>
             <a:picLocks noChangeAspect="1"/>
           </p:cNvPicPr>
@@ -3670,7 +3662,7 @@
         </p:nvSpPr>
         <p:spPr>
           <a:xfrm>
-            <a:off x="4617720" y="5715000"/>
+            <a:off x="4617720" y="5806440"/>
             <a:ext cx="7406640" cy="365760"/>
           </a:xfrm>
           <a:prstGeom prst="rect">
@@ -3696,7 +3688,7 @@
                 </a:solidFill>
                 <a:latin typeface="Segoe UI"/>
               </a:rPr>
-              <a:t>Three two-hour study windows, all fully covered by the footage.</a:t>
+              <a:t>All 16 movement corridors overlaid on the frame.</a:t>
             </a:r>
           </a:p>
         </p:txBody>
@@ -3753,7 +3745,7 @@
                 </a:solidFill>
                 <a:latin typeface="Segoe UI"/>
               </a:rPr>
-              <a:t>STEP 7 · PROCESS</a:t>
+              <a:t>STEP 5B · ▶ IN MOTION</a:t>
             </a:r>
           </a:p>
           <a:p>
@@ -3769,7 +3761,7 @@
                 </a:solidFill>
                 <a:latin typeface="Segoe UI"/>
               </a:rPr>
-              <a:t>Confirm &amp; process, then leave it alone</a:t>
+              <a:t>Drawing a channel, click by click</a:t>
             </a:r>
           </a:p>
         </p:txBody>
@@ -3808,7 +3800,7 @@
                 </a:solidFill>
                 <a:latin typeface="Segoe UI"/>
               </a:rPr>
-              <a:t>Pick a mode and go</a:t>
+              <a:t>Three clicks minimum</a:t>
             </a:r>
           </a:p>
           <a:p>
@@ -3824,7 +3816,7 @@
                 </a:solidFill>
                 <a:latin typeface="Segoe UI"/>
               </a:rPr>
-              <a:t>•  Balanced is the recommended default for full-day clips; Accurate trades speed for the hardest sites; Fast is for previews.</a:t>
+              <a:t>•  “+ New channel” arms drawing.</a:t>
             </a:r>
           </a:p>
           <a:p>
@@ -3840,7 +3832,7 @@
                 </a:solidFill>
                 <a:latin typeface="Segoe UI"/>
               </a:rPr>
-              <a:t>•  Click “Confirm &amp; process” on the card — the Processing tab tracks every intersection with live status (refreshes every 2 s).</a:t>
+              <a:t>•  Click the ENTRY at the mouth the movement uses, a BEND wherever the path curves (as many as needed), then the EXIT.</a:t>
             </a:r>
           </a:p>
           <a:p>
@@ -3856,7 +3848,7 @@
                 </a:solidFill>
                 <a:latin typeface="Segoe UI"/>
               </a:rPr>
-              <a:t>•  Single-frame glitches never stop a run; real errors surface on the status card with the reason.</a:t>
+              <a:t>•  Both ends snap to the nearest leg; the list shows the new row immediately.</a:t>
             </a:r>
           </a:p>
           <a:p>
@@ -3872,14 +3864,14 @@
                 </a:solidFill>
                 <a:latin typeface="Segoe UI"/>
               </a:rPr>
-              <a:t>⚠  While a run is active, don't edit the app's files or restart the server — the dev auto-reload kills in-flight jobs.</a:t>
+              <a:t>⚠  Nothing persists until “Save channels” — leaving the editor discards the draft (this demo was discarded).</a:t>
             </a:r>
           </a:p>
         </p:txBody>
       </p:sp>
       <p:pic>
         <p:nvPicPr>
-          <p:cNvPr id="4" name="Picture 3" descr="guide_12_processing_tab.png"/>
+          <p:cNvPr id="4" name="Picture 3" descr="gif_04_draw_channel.gif"/>
           <p:cNvPicPr>
             <a:picLocks noChangeAspect="1"/>
           </p:cNvPicPr>
@@ -3894,7 +3886,7 @@
         <p:spPr>
           <a:xfrm>
             <a:off x="4617720" y="1481328"/>
-            <a:ext cx="7406640" cy="4166235"/>
+            <a:ext cx="7406640" cy="4167918"/>
           </a:xfrm>
           <a:prstGeom prst="rect">
             <a:avLst/>
@@ -3914,7 +3906,7 @@
         </p:nvSpPr>
         <p:spPr>
           <a:xfrm>
-            <a:off x="4617720" y="5715000"/>
+            <a:off x="4617720" y="5806440"/>
             <a:ext cx="7406640" cy="365760"/>
           </a:xfrm>
           <a:prstGeom prst="rect">
@@ -3940,7 +3932,7 @@
                 </a:solidFill>
                 <a:latin typeface="Segoe UI"/>
               </a:rPr>
-              <a:t>Project-level processing status: four complete, one surfaced error.</a:t>
+              <a:t>▶ Entry → bend → exit; the draft appears in the channel list.</a:t>
             </a:r>
           </a:p>
         </p:txBody>
@@ -3997,7 +3989,7 @@
                 </a:solidFill>
                 <a:latin typeface="Segoe UI"/>
               </a:rPr>
-              <a:t>STEP 8 · QA</a:t>
+              <a:t>STEP 5C · CALIBRATION</a:t>
             </a:r>
           </a:p>
           <a:p>
@@ -4013,7 +4005,7 @@
                 </a:solidFill>
                 <a:latin typeface="Segoe UI"/>
               </a:rPr>
-              <a:t>The built-in checks run before you export</a:t>
+              <a:t>Road paths — then save</a:t>
             </a:r>
           </a:p>
         </p:txBody>
@@ -4052,7 +4044,7 @@
                 </a:solidFill>
                 <a:latin typeface="Segoe UI"/>
               </a:rPr>
-              <a:t>Trust, then verify</a:t>
+              <a:t>The observed geometry</a:t>
             </a:r>
           </a:p>
           <a:p>
@@ -4068,7 +4060,7 @@
                 </a:solidFill>
                 <a:latin typeface="Segoe UI"/>
               </a:rPr>
-              <a:t>•  Corridor flow conservation: vehicles leaving one intersection should arrive at the next — big gaps implicate counting at one end (or heavy mid-block access).</a:t>
+              <a:t>•  Road paths are machine-derived center-lines from real observed journeys — review them against the video.</a:t>
             </a:r>
           </a:p>
           <a:p>
@@ -4084,7 +4076,7 @@
                 </a:solidFill>
                 <a:latin typeface="Segoe UI"/>
               </a:rPr>
-              <a:t>•  Reverse-movement balance is informational: directional peaking in a peak window is normal.</a:t>
+              <a:t>•  A missing path for a real movement is worth fixing: draw it, or re-run auto-calibration on busier video.</a:t>
             </a:r>
           </a:p>
           <a:p>
@@ -4100,30 +4092,14 @@
                 </a:solidFill>
                 <a:latin typeface="Segoe UI"/>
               </a:rPr>
-              <a:t>•  Manual spot count: hand-count a stretch of raw video and compare — the zero-ground-truth accuracy estimate. Certifying ±10% needs roughly 850 vehicles (20–40 min at a busy site).</a:t>
-            </a:r>
-          </a:p>
-          <a:p>
-            <a:pPr algn="l">
-              <a:spcAft>
-                <a:spcPts val="600"/>
-              </a:spcAft>
-            </a:pPr>
-            <a:r>
-              <a:rPr sz="1250" b="1">
-                <a:solidFill>
-                  <a:srgbClr val="B45309"/>
-                </a:solidFill>
-                <a:latin typeface="Segoe UI"/>
-              </a:rPr>
-              <a:t>⚠  A hard FAIL needs investigation before export — flags alone won't clear it.</a:t>
+              <a:t>•  Click Save calibration — nothing persists until you do.</a:t>
             </a:r>
           </a:p>
         </p:txBody>
       </p:sp>
       <p:pic>
         <p:nvPicPr>
-          <p:cNvPr id="4" name="Picture 3" descr="guide_10_qa_checks.png"/>
+          <p:cNvPr id="4" name="Picture 3" descr="guide_08_calibration_paths.png"/>
           <p:cNvPicPr>
             <a:picLocks noChangeAspect="1"/>
           </p:cNvPicPr>
@@ -4158,7 +4134,7 @@
         </p:nvSpPr>
         <p:spPr>
           <a:xfrm>
-            <a:off x="4617720" y="5715000"/>
+            <a:off x="4617720" y="5806440"/>
             <a:ext cx="7406640" cy="365760"/>
           </a:xfrm>
           <a:prstGeom prst="rect">
@@ -4184,7 +4160,7 @@
                 </a:solidFill>
                 <a:latin typeface="Segoe UI"/>
               </a:rPr>
-              <a:t>The QA tab: conservation table with per-link OK / WARN / FAIL.</a:t>
+              <a:t>Derived road paths for every approach, ready to save.</a:t>
             </a:r>
           </a:p>
         </p:txBody>
@@ -4241,7 +4217,7 @@
                 </a:solidFill>
                 <a:latin typeface="Segoe UI"/>
               </a:rPr>
-              <a:t>STEP 8A · REVIEW</a:t>
+              <a:t>STEP 6 · TRIMS</a:t>
             </a:r>
           </a:p>
           <a:p>
@@ -4257,7 +4233,7 @@
                 </a:solidFill>
                 <a:latin typeface="Segoe UI"/>
               </a:rPr>
-              <a:t>Work the flag queue with the keyboard</a:t>
+              <a:t>Choose the windows to count</a:t>
             </a:r>
           </a:p>
         </p:txBody>
@@ -4296,7 +4272,7 @@
                 </a:solidFill>
                 <a:latin typeface="Segoe UI"/>
               </a:rPr>
-              <a:t>Cards, not spreadsheets</a:t>
+              <a:t>Wall-clock windows</a:t>
             </a:r>
           </a:p>
           <a:p>
@@ -4312,7 +4288,7 @@
                 </a:solidFill>
                 <a:latin typeface="Segoe UI"/>
               </a:rPr>
-              <a:t>•  Each card is one question — “is this movement really this small?” — with the exact video interval to scrub.</a:t>
+              <a:t>•  Each trim is a HH:MM:SS window processed across ALL cameras on the card — classic peaks here: 07–09, 11–13, 16–18.</a:t>
             </a:r>
           </a:p>
           <a:p>
@@ -4328,7 +4304,7 @@
                 </a:solidFill>
                 <a:latin typeface="Segoe UI"/>
               </a:rPr>
-              <a:t>•  Keyboard-first: Enter accepts, A adds a missed vehicle, D dismisses (real low volume), → skips, Z undoes anything.</a:t>
+              <a:t>•  Coverage confirms footage actually spans the window.</a:t>
             </a:r>
           </a:p>
           <a:p>
@@ -4344,7 +4320,7 @@
                 </a:solidFill>
                 <a:latin typeface="Segoe UI"/>
               </a:rPr>
-              <a:t>•  The sidebar keeps score: running total, estimated missed vehicles, and what's left to reach a clean queue.</a:t>
+              <a:t>•  Per-camera coverage shows each camera's true recording span.</a:t>
             </a:r>
           </a:p>
           <a:p>
@@ -4360,14 +4336,14 @@
                 </a:solidFill>
                 <a:latin typeface="Segoe UI"/>
               </a:rPr>
-              <a:t>•  The machine already closed everything it could on its own (1,648 items here) — you only see what needs human eyes.</a:t>
+              <a:t>•  Fewer, tighter trims = faster processing; full-day = overnight.</a:t>
             </a:r>
           </a:p>
         </p:txBody>
       </p:sp>
       <p:pic>
         <p:nvPicPr>
-          <p:cNvPr id="4" name="Picture 3" descr="guide_11_flag_review.png"/>
+          <p:cNvPr id="4" name="Picture 3" descr="guide_09_clip_trims.png"/>
           <p:cNvPicPr>
             <a:picLocks noChangeAspect="1"/>
           </p:cNvPicPr>
@@ -4402,7 +4378,7 @@
         </p:nvSpPr>
         <p:spPr>
           <a:xfrm>
-            <a:off x="4617720" y="5715000"/>
+            <a:off x="4617720" y="5806440"/>
             <a:ext cx="7406640" cy="365760"/>
           </a:xfrm>
           <a:prstGeom prst="rect">
@@ -4428,7 +4404,7 @@
                 </a:solidFill>
                 <a:latin typeface="Segoe UI"/>
               </a:rPr>
-              <a:t>Card 1 of 286, with the live-count sidebar and the gate status.</a:t>
+              <a:t>Three two-hour study windows, all fully covered.</a:t>
             </a:r>
           </a:p>
         </p:txBody>
@@ -4485,7 +4461,7 @@
                 </a:solidFill>
                 <a:latin typeface="Segoe UI"/>
               </a:rPr>
-              <a:t>STEP 9 · EXPORT</a:t>
+              <a:t>STEP 7 · PROCESS</a:t>
             </a:r>
           </a:p>
           <a:p>
@@ -4501,7 +4477,7 @@
                 </a:solidFill>
                 <a:latin typeface="Segoe UI"/>
               </a:rPr>
-              <a:t>Excel and PDF, straight from the card</a:t>
+              <a:t>Confirm &amp; process, then leave it alone</a:t>
             </a:r>
           </a:p>
         </p:txBody>
@@ -4540,7 +4516,7 @@
                 </a:solidFill>
                 <a:latin typeface="Segoe UI"/>
               </a:rPr>
-              <a:t>The deliverable</a:t>
+              <a:t>Pick a mode and go</a:t>
             </a:r>
           </a:p>
           <a:p>
@@ -4556,7 +4532,7 @@
                 </a:solidFill>
                 <a:latin typeface="Segoe UI"/>
               </a:rPr>
-              <a:t>•  Excel and PDF buttons sit on each intersection card — export once the QA gate is clean.</a:t>
+              <a:t>•  Balanced is the default for full-day clips; Accurate trades speed for the hardest sites; Fast is for previews.</a:t>
             </a:r>
           </a:p>
           <a:p>
@@ -4572,7 +4548,7 @@
                 </a:solidFill>
                 <a:latin typeface="Segoe UI"/>
               </a:rPr>
-              <a:t>•  The workbook is a standard TMC layout: per-bin turning counts as hard-coded integers — no formulas, safe to hand to any client tool.</a:t>
+              <a:t>•  The Processing tab tracks every intersection live (2 s refresh).</a:t>
             </a:r>
           </a:p>
           <a:p>
@@ -4588,30 +4564,30 @@
                 </a:solidFill>
                 <a:latin typeface="Segoe UI"/>
               </a:rPr>
-              <a:t>•  Every export reflects the current reviewed state — re-export any time after further review.</a:t>
-            </a:r>
-          </a:p>
-          <a:p>
-            <a:pPr algn="l">
-              <a:spcAft>
-                <a:spcPts val="700"/>
-              </a:spcAft>
-            </a:pPr>
-            <a:r>
-              <a:rPr sz="1350" b="0">
-                <a:solidFill>
-                  <a:srgbClr val="374151"/>
-                </a:solidFill>
-                <a:latin typeface="Segoe UI"/>
-              </a:rPr>
-              <a:t>•  PDF gives the same counts in a shareable report format.</a:t>
+              <a:t>•  Single-frame glitches never stop a run; real errors surface on the status card with the reason.</a:t>
+            </a:r>
+          </a:p>
+          <a:p>
+            <a:pPr algn="l">
+              <a:spcAft>
+                <a:spcPts val="600"/>
+              </a:spcAft>
+            </a:pPr>
+            <a:r>
+              <a:rPr sz="1250" b="1">
+                <a:solidFill>
+                  <a:srgbClr val="B45309"/>
+                </a:solidFill>
+                <a:latin typeface="Segoe UI"/>
+              </a:rPr>
+              <a:t>⚠  While a run is active, don't edit the app's files or restart the server — the dev auto-reload kills in-flight jobs.</a:t>
             </a:r>
           </a:p>
         </p:txBody>
       </p:sp>
       <p:pic>
         <p:nvPicPr>
-          <p:cNvPr id="4" name="Picture 3" descr="guide_03_intersections_tab.png"/>
+          <p:cNvPr id="4" name="Picture 3" descr="guide_12_processing_tab.png"/>
           <p:cNvPicPr>
             <a:picLocks noChangeAspect="1"/>
           </p:cNvPicPr>
@@ -4646,7 +4622,7 @@
         </p:nvSpPr>
         <p:spPr>
           <a:xfrm>
-            <a:off x="4617720" y="5715000"/>
+            <a:off x="4617720" y="5806440"/>
             <a:ext cx="7406640" cy="365760"/>
           </a:xfrm>
           <a:prstGeom prst="rect">
@@ -4672,7 +4648,7 @@
                 </a:solidFill>
                 <a:latin typeface="Segoe UI"/>
               </a:rPr>
-              <a:t>Excel / PDF export lives on the intersection cards.</a:t>
+              <a:t>Project-level status: four complete, one surfaced error.</a:t>
             </a:r>
           </a:p>
         </p:txBody>
@@ -4729,7 +4705,7 @@
                 </a:solidFill>
                 <a:latin typeface="Segoe UI"/>
               </a:rPr>
-              <a:t>REFERENCE</a:t>
+              <a:t>STEP 7A · STATUS CARDS</a:t>
             </a:r>
           </a:p>
           <a:p>
@@ -4745,7 +4721,7 @@
                 </a:solidFill>
                 <a:latin typeface="Segoe UI"/>
               </a:rPr>
-              <a:t>Tips, traps, and quick answers</a:t>
+              <a:t>Reading a surfaced error (the one on screen)</a:t>
             </a:r>
           </a:p>
         </p:txBody>
@@ -4758,8 +4734,8 @@
         </p:nvSpPr>
         <p:spPr>
           <a:xfrm>
-            <a:off x="502920" y="1463040"/>
-            <a:ext cx="5486400" cy="5120640"/>
+            <a:off x="502920" y="1417320"/>
+            <a:ext cx="4251960" cy="5120640"/>
           </a:xfrm>
           <a:prstGeom prst="rect">
             <a:avLst/>
@@ -4780,11 +4756,11 @@
             <a:r>
               <a:rPr sz="1400" b="1">
                 <a:solidFill>
-                  <a:srgbClr val="2563EB"/>
-                </a:solidFill>
-                <a:latin typeface="Segoe UI"/>
-              </a:rPr>
-              <a:t>Launching</a:t>
+                  <a:srgbClr val="1F2937"/>
+                </a:solidFill>
+                <a:latin typeface="Segoe UI"/>
+              </a:rPr>
+              <a:t>Status = the LAST run's result</a:t>
             </a:r>
           </a:p>
           <a:p>
@@ -4794,13 +4770,13 @@
               </a:spcAft>
             </a:pPr>
             <a:r>
-              <a:rPr sz="1300" b="0">
-                <a:solidFill>
-                  <a:srgbClr val="374151"/>
-                </a:solidFill>
-                <a:latin typeface="Segoe UI"/>
-              </a:rPr>
-              <a:t>•  The app lives at http://127.0.0.1:5000 — that port only. The optional desktop window is  python run.pyw.</a:t>
+              <a:rPr sz="1350" b="0">
+                <a:solidFill>
+                  <a:srgbClr val="374151"/>
+                </a:solidFill>
+                <a:latin typeface="Segoe UI"/>
+              </a:rPr>
+              <a:t>•  Each card stores its most recent run's outcome and timestamp — an Error stays displayed until the next run replaces it.</a:t>
             </a:r>
           </a:p>
           <a:p>
@@ -4810,29 +4786,13 @@
               </a:spcAft>
             </a:pPr>
             <a:r>
-              <a:rPr sz="1300" b="0">
-                <a:solidFill>
-                  <a:srgbClr val="374151"/>
-                </a:solidFill>
-                <a:latin typeface="Segoe UI"/>
-              </a:rPr>
-              <a:t>•  Everything runs locally: no internet needed after install, and footage never leaves the machine.</a:t>
-            </a:r>
-          </a:p>
-          <a:p>
-            <a:pPr algn="l">
-              <a:spcAft>
-                <a:spcPts val="400"/>
-              </a:spcAft>
-            </a:pPr>
-            <a:r>
-              <a:rPr sz="1400" b="1">
-                <a:solidFill>
-                  <a:srgbClr val="2563EB"/>
-                </a:solidFill>
-                <a:latin typeface="Segoe UI"/>
-              </a:rPr>
-              <a:t>Calibration</a:t>
+              <a:rPr sz="1350" b="0">
+                <a:solidFill>
+                  <a:srgbClr val="374151"/>
+                </a:solidFill>
+                <a:latin typeface="Segoe UI"/>
+              </a:rPr>
+              <a:t>•  This one: “no such column: origin_posterior_json”, dated 2026-07-31 — that run raced an app update (the database column now exists). It is stale, not live.</a:t>
             </a:r>
           </a:p>
           <a:p>
@@ -4842,59 +4802,72 @@
               </a:spcAft>
             </a:pPr>
             <a:r>
-              <a:rPr sz="1300" b="0">
-                <a:solidFill>
-                  <a:srgbClr val="374151"/>
-                </a:solidFill>
-                <a:latin typeface="Segoe UI"/>
-              </a:rPr>
-              <a:t>•  T-junction? Set legs to 3 on the card first — the editor and movement names follow it.</a:t>
-            </a:r>
-          </a:p>
-          <a:p>
-            <a:pPr algn="l">
-              <a:spcAft>
-                <a:spcPts val="700"/>
-              </a:spcAft>
-            </a:pPr>
-            <a:r>
-              <a:rPr sz="1300" b="0">
-                <a:solidFill>
-                  <a:srgbClr val="374151"/>
-                </a:solidFill>
-                <a:latin typeface="Segoe UI"/>
-              </a:rPr>
-              <a:t>•  Channels are guidance, not fences: draw every movement incl. throughs, and trust the trajectory to decide the turn.</a:t>
-            </a:r>
-          </a:p>
-          <a:p>
-            <a:pPr algn="l">
-              <a:spcAft>
-                <a:spcPts val="700"/>
-              </a:spcAft>
-            </a:pPr>
-            <a:r>
-              <a:rPr sz="1300" b="0">
-                <a:solidFill>
-                  <a:srgbClr val="374151"/>
-                </a:solidFill>
-                <a:latin typeface="Segoe UI"/>
-              </a:rPr>
-              <a:t>•  Auto-calibration improves with busier video — scrub to a busy period before running it.</a:t>
-            </a:r>
-          </a:p>
-        </p:txBody>
-      </p:sp>
-      <p:sp>
-        <p:nvSpPr>
-          <p:cNvPr id="4" name="TextBox 3"/>
+              <a:rPr sz="1350" b="0">
+                <a:solidFill>
+                  <a:srgbClr val="374151"/>
+                </a:solidFill>
+                <a:latin typeface="Segoe UI"/>
+              </a:rPr>
+              <a:t>•  Counts already produced for this intersection are unaffected — the error describes the failed run, not the data.</a:t>
+            </a:r>
+          </a:p>
+          <a:p>
+            <a:pPr algn="l">
+              <a:spcAft>
+                <a:spcPts val="600"/>
+              </a:spcAft>
+            </a:pPr>
+            <a:r>
+              <a:rPr sz="1250" b="1">
+                <a:solidFill>
+                  <a:srgbClr val="0E7A4E"/>
+                </a:solidFill>
+                <a:latin typeface="Segoe UI"/>
+              </a:rPr>
+              <a:t>Fix: simply run “Confirm &amp; process” again when you next process this card; the fresh run replaces the status. If the same error recurs on a current version, report it — that means the project file predates the app.</a:t>
+            </a:r>
+          </a:p>
+        </p:txBody>
+      </p:sp>
+      <p:pic>
+        <p:nvPicPr>
+          <p:cNvPr id="4" name="Picture 3" descr="zoom_processing_error.png"/>
+          <p:cNvPicPr>
+            <a:picLocks noChangeAspect="1"/>
+          </p:cNvPicPr>
+          <p:nvPr/>
+        </p:nvPicPr>
+        <p:blipFill>
+          <a:blip r:embed="rId2"/>
+          <a:stretch>
+            <a:fillRect/>
+          </a:stretch>
+        </p:blipFill>
+        <p:spPr>
+          <a:xfrm>
+            <a:off x="4892040" y="1481328"/>
+            <a:ext cx="6949440" cy="1116874"/>
+          </a:xfrm>
+          <a:prstGeom prst="rect">
+            <a:avLst/>
+          </a:prstGeom>
+          <a:ln w="12700">
+            <a:solidFill>
+              <a:srgbClr val="D1D5DB"/>
+            </a:solidFill>
+          </a:ln>
+        </p:spPr>
+      </p:pic>
+      <p:sp>
+        <p:nvSpPr>
+          <p:cNvPr id="5" name="TextBox 4"/>
           <p:cNvSpPr txBox="1"/>
           <p:nvPr/>
         </p:nvSpPr>
         <p:spPr>
           <a:xfrm>
-            <a:off x="6309360" y="1463040"/>
-            <a:ext cx="5486400" cy="5120640"/>
+            <a:off x="4892040" y="5806440"/>
+            <a:ext cx="6949440" cy="365760"/>
           </a:xfrm>
           <a:prstGeom prst="rect">
             <a:avLst/>
@@ -4909,17 +4882,373 @@
           <a:p>
             <a:pPr algn="l">
               <a:spcAft>
+                <a:spcPts val="0"/>
+              </a:spcAft>
+            </a:pPr>
+            <a:r>
+              <a:rPr sz="1050" b="0">
+                <a:solidFill>
+                  <a:srgbClr val="6B7280"/>
+                </a:solidFill>
+                <a:latin typeface="Segoe UI"/>
+              </a:rPr>
+              <a:t>Zoom of the error card: the reason and the Open shortcut.</a:t>
+            </a:r>
+          </a:p>
+        </p:txBody>
+      </p:sp>
+    </p:spTree>
+  </p:cSld>
+  <p:clrMapOvr>
+    <a:masterClrMapping/>
+  </p:clrMapOvr>
+</p:sld>
+</file>
+
+<file path=ppt/slides/slide17.xml><?xml version="1.0" encoding="utf-8"?>
+<p:sld xmlns:a="http://schemas.openxmlformats.org/drawingml/2006/main" xmlns:p="http://schemas.openxmlformats.org/presentationml/2006/main" xmlns:r="http://schemas.openxmlformats.org/officeDocument/2006/relationships">
+  <p:cSld>
+    <p:spTree>
+      <p:nvGrpSpPr>
+        <p:cNvPr id="1" name=""/>
+        <p:cNvGrpSpPr/>
+        <p:nvPr/>
+      </p:nvGrpSpPr>
+      <p:grpSpPr/>
+      <p:sp>
+        <p:nvSpPr>
+          <p:cNvPr id="2" name="TextBox 1"/>
+          <p:cNvSpPr txBox="1"/>
+          <p:nvPr/>
+        </p:nvSpPr>
+        <p:spPr>
+          <a:xfrm>
+            <a:off x="502920" y="256032"/>
+            <a:ext cx="11247120" cy="1005840"/>
+          </a:xfrm>
+          <a:prstGeom prst="rect">
+            <a:avLst/>
+          </a:prstGeom>
+          <a:noFill/>
+        </p:spPr>
+        <p:txBody>
+          <a:bodyPr wrap="square">
+            <a:spAutoFit/>
+          </a:bodyPr>
+          <a:lstStyle/>
+          <a:p>
+            <a:pPr algn="l">
+              <a:spcAft>
+                <a:spcPts val="200"/>
+              </a:spcAft>
+            </a:pPr>
+            <a:r>
+              <a:rPr sz="1200" b="1">
+                <a:solidFill>
+                  <a:srgbClr val="2563EB"/>
+                </a:solidFill>
+                <a:latin typeface="Segoe UI"/>
+              </a:rPr>
+              <a:t>STEP 8 · QA</a:t>
+            </a:r>
+          </a:p>
+          <a:p>
+            <a:pPr algn="l">
+              <a:spcAft>
+                <a:spcPts val="0"/>
+              </a:spcAft>
+            </a:pPr>
+            <a:r>
+              <a:rPr sz="2600" b="1">
+                <a:solidFill>
+                  <a:srgbClr val="1F2937"/>
+                </a:solidFill>
+                <a:latin typeface="Segoe UI"/>
+              </a:rPr>
+              <a:t>The built-in checks run before you export</a:t>
+            </a:r>
+          </a:p>
+        </p:txBody>
+      </p:sp>
+      <p:sp>
+        <p:nvSpPr>
+          <p:cNvPr id="3" name="TextBox 2"/>
+          <p:cNvSpPr txBox="1"/>
+          <p:nvPr/>
+        </p:nvSpPr>
+        <p:spPr>
+          <a:xfrm>
+            <a:off x="502920" y="1417320"/>
+            <a:ext cx="3977639" cy="5120640"/>
+          </a:xfrm>
+          <a:prstGeom prst="rect">
+            <a:avLst/>
+          </a:prstGeom>
+          <a:noFill/>
+        </p:spPr>
+        <p:txBody>
+          <a:bodyPr wrap="square">
+            <a:spAutoFit/>
+          </a:bodyPr>
+          <a:lstStyle/>
+          <a:p>
+            <a:pPr algn="l">
+              <a:spcAft>
                 <a:spcPts val="400"/>
               </a:spcAft>
             </a:pPr>
             <a:r>
               <a:rPr sz="1400" b="1">
                 <a:solidFill>
+                  <a:srgbClr val="1F2937"/>
+                </a:solidFill>
+                <a:latin typeface="Segoe UI"/>
+              </a:rPr>
+              <a:t>Trust, then verify</a:t>
+            </a:r>
+          </a:p>
+          <a:p>
+            <a:pPr algn="l">
+              <a:spcAft>
+                <a:spcPts val="700"/>
+              </a:spcAft>
+            </a:pPr>
+            <a:r>
+              <a:rPr sz="1350" b="0">
+                <a:solidFill>
+                  <a:srgbClr val="374151"/>
+                </a:solidFill>
+                <a:latin typeface="Segoe UI"/>
+              </a:rPr>
+              <a:t>•  Corridor flow conservation: vehicles leaving one intersection should arrive at the next — big gaps implicate counting at one end, or heavy mid-block access.</a:t>
+            </a:r>
+          </a:p>
+          <a:p>
+            <a:pPr algn="l">
+              <a:spcAft>
+                <a:spcPts val="700"/>
+              </a:spcAft>
+            </a:pPr>
+            <a:r>
+              <a:rPr sz="1350" b="0">
+                <a:solidFill>
+                  <a:srgbClr val="374151"/>
+                </a:solidFill>
+                <a:latin typeface="Segoe UI"/>
+              </a:rPr>
+              <a:t>•  Reverse-movement balance is informational in peak windows.</a:t>
+            </a:r>
+          </a:p>
+          <a:p>
+            <a:pPr algn="l">
+              <a:spcAft>
+                <a:spcPts val="700"/>
+              </a:spcAft>
+            </a:pPr>
+            <a:r>
+              <a:rPr sz="1350" b="0">
+                <a:solidFill>
+                  <a:srgbClr val="374151"/>
+                </a:solidFill>
+                <a:latin typeface="Segoe UI"/>
+              </a:rPr>
+              <a:t>•  Manual spot count: hand-count a stretch of raw video and compare — the zero-ground-truth accuracy estimate. Certifying ±10% needs ~850 vehicles (20–40 min busy).</a:t>
+            </a:r>
+          </a:p>
+          <a:p>
+            <a:pPr algn="l">
+              <a:spcAft>
+                <a:spcPts val="600"/>
+              </a:spcAft>
+            </a:pPr>
+            <a:r>
+              <a:rPr sz="1250" b="1">
+                <a:solidFill>
+                  <a:srgbClr val="B45309"/>
+                </a:solidFill>
+                <a:latin typeface="Segoe UI"/>
+              </a:rPr>
+              <a:t>⚠  A hard FAIL needs investigation before export — work the QA tab for the implicated link; flags alone won't clear it.</a:t>
+            </a:r>
+          </a:p>
+        </p:txBody>
+      </p:sp>
+      <p:pic>
+        <p:nvPicPr>
+          <p:cNvPr id="4" name="Picture 3" descr="guide_10_qa_checks.png"/>
+          <p:cNvPicPr>
+            <a:picLocks noChangeAspect="1"/>
+          </p:cNvPicPr>
+          <p:nvPr/>
+        </p:nvPicPr>
+        <p:blipFill>
+          <a:blip r:embed="rId2"/>
+          <a:stretch>
+            <a:fillRect/>
+          </a:stretch>
+        </p:blipFill>
+        <p:spPr>
+          <a:xfrm>
+            <a:off x="4617720" y="1481328"/>
+            <a:ext cx="7406640" cy="4166235"/>
+          </a:xfrm>
+          <a:prstGeom prst="rect">
+            <a:avLst/>
+          </a:prstGeom>
+          <a:ln w="12700">
+            <a:solidFill>
+              <a:srgbClr val="D1D5DB"/>
+            </a:solidFill>
+          </a:ln>
+        </p:spPr>
+      </p:pic>
+      <p:sp>
+        <p:nvSpPr>
+          <p:cNvPr id="5" name="TextBox 4"/>
+          <p:cNvSpPr txBox="1"/>
+          <p:nvPr/>
+        </p:nvSpPr>
+        <p:spPr>
+          <a:xfrm>
+            <a:off x="4617720" y="5806440"/>
+            <a:ext cx="7406640" cy="365760"/>
+          </a:xfrm>
+          <a:prstGeom prst="rect">
+            <a:avLst/>
+          </a:prstGeom>
+          <a:noFill/>
+        </p:spPr>
+        <p:txBody>
+          <a:bodyPr wrap="square">
+            <a:spAutoFit/>
+          </a:bodyPr>
+          <a:lstStyle/>
+          <a:p>
+            <a:pPr algn="l">
+              <a:spcAft>
+                <a:spcPts val="0"/>
+              </a:spcAft>
+            </a:pPr>
+            <a:r>
+              <a:rPr sz="1050" b="0">
+                <a:solidFill>
+                  <a:srgbClr val="6B7280"/>
+                </a:solidFill>
+                <a:latin typeface="Segoe UI"/>
+              </a:rPr>
+              <a:t>The QA tab: conservation with per-link OK / WARN / FAIL.</a:t>
+            </a:r>
+          </a:p>
+        </p:txBody>
+      </p:sp>
+    </p:spTree>
+  </p:cSld>
+  <p:clrMapOvr>
+    <a:masterClrMapping/>
+  </p:clrMapOvr>
+</p:sld>
+</file>
+
+<file path=ppt/slides/slide18.xml><?xml version="1.0" encoding="utf-8"?>
+<p:sld xmlns:a="http://schemas.openxmlformats.org/drawingml/2006/main" xmlns:p="http://schemas.openxmlformats.org/presentationml/2006/main" xmlns:r="http://schemas.openxmlformats.org/officeDocument/2006/relationships">
+  <p:cSld>
+    <p:spTree>
+      <p:nvGrpSpPr>
+        <p:cNvPr id="1" name=""/>
+        <p:cNvGrpSpPr/>
+        <p:nvPr/>
+      </p:nvGrpSpPr>
+      <p:grpSpPr/>
+      <p:sp>
+        <p:nvSpPr>
+          <p:cNvPr id="2" name="TextBox 1"/>
+          <p:cNvSpPr txBox="1"/>
+          <p:nvPr/>
+        </p:nvSpPr>
+        <p:spPr>
+          <a:xfrm>
+            <a:off x="502920" y="256032"/>
+            <a:ext cx="11247120" cy="1005840"/>
+          </a:xfrm>
+          <a:prstGeom prst="rect">
+            <a:avLst/>
+          </a:prstGeom>
+          <a:noFill/>
+        </p:spPr>
+        <p:txBody>
+          <a:bodyPr wrap="square">
+            <a:spAutoFit/>
+          </a:bodyPr>
+          <a:lstStyle/>
+          <a:p>
+            <a:pPr algn="l">
+              <a:spcAft>
+                <a:spcPts val="200"/>
+              </a:spcAft>
+            </a:pPr>
+            <a:r>
+              <a:rPr sz="1200" b="1">
+                <a:solidFill>
                   <a:srgbClr val="2563EB"/>
                 </a:solidFill>
                 <a:latin typeface="Segoe UI"/>
               </a:rPr>
-              <a:t>Processing</a:t>
+              <a:t>STEP 8A · THE FLAG QUEUE</a:t>
+            </a:r>
+          </a:p>
+          <a:p>
+            <a:pPr algn="l">
+              <a:spcAft>
+                <a:spcPts val="0"/>
+              </a:spcAft>
+            </a:pPr>
+            <a:r>
+              <a:rPr sz="2600" b="1">
+                <a:solidFill>
+                  <a:srgbClr val="1F2937"/>
+                </a:solidFill>
+                <a:latin typeface="Segoe UI"/>
+              </a:rPr>
+              <a:t>Anatomy of a review card</a:t>
+            </a:r>
+          </a:p>
+        </p:txBody>
+      </p:sp>
+      <p:sp>
+        <p:nvSpPr>
+          <p:cNvPr id="3" name="TextBox 2"/>
+          <p:cNvSpPr txBox="1"/>
+          <p:nvPr/>
+        </p:nvSpPr>
+        <p:spPr>
+          <a:xfrm>
+            <a:off x="502920" y="1417320"/>
+            <a:ext cx="3977639" cy="5120640"/>
+          </a:xfrm>
+          <a:prstGeom prst="rect">
+            <a:avLst/>
+          </a:prstGeom>
+          <a:noFill/>
+        </p:spPr>
+        <p:txBody>
+          <a:bodyPr wrap="square">
+            <a:spAutoFit/>
+          </a:bodyPr>
+          <a:lstStyle/>
+          <a:p>
+            <a:pPr algn="l">
+              <a:spcAft>
+                <a:spcPts val="400"/>
+              </a:spcAft>
+            </a:pPr>
+            <a:r>
+              <a:rPr sz="1400" b="1">
+                <a:solidFill>
+                  <a:srgbClr val="1F2937"/>
+                </a:solidFill>
+                <a:latin typeface="Segoe UI"/>
+              </a:rPr>
+              <a:t>One card = one question</a:t>
             </a:r>
           </a:p>
           <a:p>
@@ -4929,13 +5258,13 @@
               </a:spcAft>
             </a:pPr>
             <a:r>
-              <a:rPr sz="1300" b="0">
-                <a:solidFill>
-                  <a:srgbClr val="374151"/>
-                </a:solidFill>
-                <a:latin typeface="Segoe UI"/>
-              </a:rPr>
-              <a:t>•  Full-day footage in Balanced mode is an overnight run — start it at the end of the day.</a:t>
+              <a:rPr sz="1350" b="0">
+                <a:solidFill>
+                  <a:srgbClr val="374151"/>
+                </a:solidFill>
+                <a:latin typeface="Segoe UI"/>
+              </a:rPr>
+              <a:t>•  Header: the question (“Is this movement really this small?”, “Did the system miss vehicles here?”).</a:t>
             </a:r>
           </a:p>
           <a:p>
@@ -4945,77 +5274,913 @@
               </a:spcAft>
             </a:pPr>
             <a:r>
-              <a:rPr sz="1300" b="0">
-                <a:solidFill>
-                  <a:srgbClr val="374151"/>
-                </a:solidFill>
-                <a:latin typeface="Segoe UI"/>
-              </a:rPr>
-              <a:t>•  Don't edit application files or restart the server mid-run; the auto-reloader kills in-flight jobs.</a:t>
-            </a:r>
-          </a:p>
-          <a:p>
-            <a:pPr algn="l">
-              <a:spcAft>
-                <a:spcPts val="400"/>
-              </a:spcAft>
-            </a:pPr>
-            <a:r>
-              <a:rPr sz="1400" b="1">
+              <a:rPr sz="1350" b="0">
+                <a:solidFill>
+                  <a:srgbClr val="374151"/>
+                </a:solidFill>
+                <a:latin typeface="Segoe UI"/>
+              </a:rPr>
+              <a:t>•  Evidence line: exactly why it was flagged, with numbers — which approach, which 15-min bin, how big the suspected gap is.</a:t>
+            </a:r>
+          </a:p>
+          <a:p>
+            <a:pPr algn="l">
+              <a:spcAft>
+                <a:spcPts val="700"/>
+              </a:spcAft>
+            </a:pPr>
+            <a:r>
+              <a:rPr sz="1350" b="0">
+                <a:solidFill>
+                  <a:srgbClr val="374151"/>
+                </a:solidFill>
+                <a:latin typeface="Segoe UI"/>
+              </a:rPr>
+              <a:t>•  Interval player: the raw video for that exact window — scrub it and watch the flagged approach.</a:t>
+            </a:r>
+          </a:p>
+          <a:p>
+            <a:pPr algn="l">
+              <a:spcAft>
+                <a:spcPts val="700"/>
+              </a:spcAft>
+            </a:pPr>
+            <a:r>
+              <a:rPr sz="1350" b="0">
+                <a:solidFill>
+                  <a:srgbClr val="374151"/>
+                </a:solidFill>
+                <a:latin typeface="Segoe UI"/>
+              </a:rPr>
+              <a:t>•  Actions: A add-missed · Done · D dismiss · → skip.</a:t>
+            </a:r>
+          </a:p>
+          <a:p>
+            <a:pPr algn="l">
+              <a:spcAft>
+                <a:spcPts val="700"/>
+              </a:spcAft>
+            </a:pPr>
+            <a:r>
+              <a:rPr sz="1350" b="0">
+                <a:solidFill>
+                  <a:srgbClr val="374151"/>
+                </a:solidFill>
+                <a:latin typeface="Segoe UI"/>
+              </a:rPr>
+              <a:t>•  The machine already closed 1,648 items on its own (out-of-window, redundant, tiny holes) — you only see what needs human eyes.</a:t>
+            </a:r>
+          </a:p>
+        </p:txBody>
+      </p:sp>
+      <p:pic>
+        <p:nvPicPr>
+          <p:cNvPr id="4" name="Picture 3" descr="guide_11_flag_review.png"/>
+          <p:cNvPicPr>
+            <a:picLocks noChangeAspect="1"/>
+          </p:cNvPicPr>
+          <p:nvPr/>
+        </p:nvPicPr>
+        <p:blipFill>
+          <a:blip r:embed="rId2"/>
+          <a:stretch>
+            <a:fillRect/>
+          </a:stretch>
+        </p:blipFill>
+        <p:spPr>
+          <a:xfrm>
+            <a:off x="4617720" y="1481328"/>
+            <a:ext cx="7406640" cy="4166235"/>
+          </a:xfrm>
+          <a:prstGeom prst="rect">
+            <a:avLst/>
+          </a:prstGeom>
+          <a:ln w="12700">
+            <a:solidFill>
+              <a:srgbClr val="D1D5DB"/>
+            </a:solidFill>
+          </a:ln>
+        </p:spPr>
+      </p:pic>
+      <p:sp>
+        <p:nvSpPr>
+          <p:cNvPr id="5" name="TextBox 4"/>
+          <p:cNvSpPr txBox="1"/>
+          <p:nvPr/>
+        </p:nvSpPr>
+        <p:spPr>
+          <a:xfrm>
+            <a:off x="4617720" y="5806440"/>
+            <a:ext cx="7406640" cy="365760"/>
+          </a:xfrm>
+          <a:prstGeom prst="rect">
+            <a:avLst/>
+          </a:prstGeom>
+          <a:noFill/>
+        </p:spPr>
+        <p:txBody>
+          <a:bodyPr wrap="square">
+            <a:spAutoFit/>
+          </a:bodyPr>
+          <a:lstStyle/>
+          <a:p>
+            <a:pPr algn="l">
+              <a:spcAft>
+                <a:spcPts val="0"/>
+              </a:spcAft>
+            </a:pPr>
+            <a:r>
+              <a:rPr sz="1050" b="0">
+                <a:solidFill>
+                  <a:srgbClr val="6B7280"/>
+                </a:solidFill>
+                <a:latin typeface="Segoe UI"/>
+              </a:rPr>
+              <a:t>Card 1 of 286 with the live-count sidebar and gate panel.</a:t>
+            </a:r>
+          </a:p>
+        </p:txBody>
+      </p:sp>
+    </p:spTree>
+  </p:cSld>
+  <p:clrMapOvr>
+    <a:masterClrMapping/>
+  </p:clrMapOvr>
+</p:sld>
+</file>
+
+<file path=ppt/slides/slide19.xml><?xml version="1.0" encoding="utf-8"?>
+<p:sld xmlns:a="http://schemas.openxmlformats.org/drawingml/2006/main" xmlns:p="http://schemas.openxmlformats.org/presentationml/2006/main" xmlns:r="http://schemas.openxmlformats.org/officeDocument/2006/relationships">
+  <p:cSld>
+    <p:spTree>
+      <p:nvGrpSpPr>
+        <p:cNvPr id="1" name=""/>
+        <p:cNvGrpSpPr/>
+        <p:nvPr/>
+      </p:nvGrpSpPr>
+      <p:grpSpPr/>
+      <p:sp>
+        <p:nvSpPr>
+          <p:cNvPr id="2" name="TextBox 1"/>
+          <p:cNvSpPr txBox="1"/>
+          <p:nvPr/>
+        </p:nvSpPr>
+        <p:spPr>
+          <a:xfrm>
+            <a:off x="502920" y="256032"/>
+            <a:ext cx="11247120" cy="1005840"/>
+          </a:xfrm>
+          <a:prstGeom prst="rect">
+            <a:avLst/>
+          </a:prstGeom>
+          <a:noFill/>
+        </p:spPr>
+        <p:txBody>
+          <a:bodyPr wrap="square">
+            <a:spAutoFit/>
+          </a:bodyPr>
+          <a:lstStyle/>
+          <a:p>
+            <a:pPr algn="l">
+              <a:spcAft>
+                <a:spcPts val="200"/>
+              </a:spcAft>
+            </a:pPr>
+            <a:r>
+              <a:rPr sz="1200" b="1">
                 <a:solidFill>
                   <a:srgbClr val="2563EB"/>
                 </a:solidFill>
                 <a:latin typeface="Segoe UI"/>
               </a:rPr>
-              <a:t>QA &amp; export</a:t>
-            </a:r>
-          </a:p>
-          <a:p>
-            <a:pPr algn="l">
-              <a:spcAft>
-                <a:spcPts val="700"/>
-              </a:spcAft>
-            </a:pPr>
-            <a:r>
-              <a:rPr sz="1300" b="0">
-                <a:solidFill>
-                  <a:srgbClr val="374151"/>
-                </a:solidFill>
-                <a:latin typeface="Segoe UI"/>
-              </a:rPr>
-              <a:t>•  Work flags with the keyboard — it is 3–4× faster than the mouse.</a:t>
-            </a:r>
-          </a:p>
-          <a:p>
-            <a:pPr algn="l">
-              <a:spcAft>
-                <a:spcPts val="700"/>
-              </a:spcAft>
-            </a:pPr>
-            <a:r>
-              <a:rPr sz="1300" b="0">
-                <a:solidFill>
-                  <a:srgbClr val="374151"/>
-                </a:solidFill>
-                <a:latin typeface="Segoe UI"/>
-              </a:rPr>
-              <a:t>•  Record a spot count on every study: it is your accuracy evidence when there is no ground truth.</a:t>
-            </a:r>
-          </a:p>
-          <a:p>
-            <a:pPr algn="l">
-              <a:spcAft>
-                <a:spcPts val="700"/>
-              </a:spcAft>
-            </a:pPr>
-            <a:r>
-              <a:rPr sz="1300" b="0">
-                <a:solidFill>
-                  <a:srgbClr val="374151"/>
-                </a:solidFill>
-                <a:latin typeface="Segoe UI"/>
-              </a:rPr>
-              <a:t>•  Export is per intersection card; re-export freely after review.</a:t>
+              <a:t>STEP 8A · CARD TYPES</a:t>
+            </a:r>
+          </a:p>
+          <a:p>
+            <a:pPr algn="l">
+              <a:spcAft>
+                <a:spcPts val="0"/>
+              </a:spcAft>
+            </a:pPr>
+            <a:r>
+              <a:rPr sz="2600" b="1">
+                <a:solidFill>
+                  <a:srgbClr val="1F2937"/>
+                </a:solidFill>
+                <a:latin typeface="Segoe UI"/>
+              </a:rPr>
+              <a:t>The three card families and the right response</a:t>
+            </a:r>
+          </a:p>
+        </p:txBody>
+      </p:sp>
+      <p:sp>
+        <p:nvSpPr>
+          <p:cNvPr id="3" name="TextBox 2"/>
+          <p:cNvSpPr txBox="1"/>
+          <p:nvPr/>
+        </p:nvSpPr>
+        <p:spPr>
+          <a:xfrm>
+            <a:off x="502920" y="1417320"/>
+            <a:ext cx="2697480" cy="1143000"/>
+          </a:xfrm>
+          <a:prstGeom prst="rect">
+            <a:avLst/>
+          </a:prstGeom>
+          <a:noFill/>
+        </p:spPr>
+        <p:txBody>
+          <a:bodyPr wrap="square">
+            <a:spAutoFit/>
+          </a:bodyPr>
+          <a:lstStyle/>
+          <a:p>
+            <a:pPr algn="l">
+              <a:spcAft>
+                <a:spcPts val="0"/>
+              </a:spcAft>
+            </a:pPr>
+            <a:r>
+              <a:rPr sz="1250" b="1">
+                <a:solidFill>
+                  <a:srgbClr val="2563EB"/>
+                </a:solidFill>
+                <a:latin typeface="Segoe UI"/>
+              </a:rPr>
+              <a:t>Card family</a:t>
+            </a:r>
+          </a:p>
+        </p:txBody>
+      </p:sp>
+      <p:sp>
+        <p:nvSpPr>
+          <p:cNvPr id="4" name="TextBox 3"/>
+          <p:cNvSpPr txBox="1"/>
+          <p:nvPr/>
+        </p:nvSpPr>
+        <p:spPr>
+          <a:xfrm>
+            <a:off x="3337560" y="1417320"/>
+            <a:ext cx="3246120" cy="1143000"/>
+          </a:xfrm>
+          <a:prstGeom prst="rect">
+            <a:avLst/>
+          </a:prstGeom>
+          <a:noFill/>
+        </p:spPr>
+        <p:txBody>
+          <a:bodyPr wrap="square">
+            <a:spAutoFit/>
+          </a:bodyPr>
+          <a:lstStyle/>
+          <a:p>
+            <a:pPr algn="l">
+              <a:spcAft>
+                <a:spcPts val="0"/>
+              </a:spcAft>
+            </a:pPr>
+            <a:r>
+              <a:rPr sz="1250" b="1">
+                <a:solidFill>
+                  <a:srgbClr val="2563EB"/>
+                </a:solidFill>
+                <a:latin typeface="Segoe UI"/>
+              </a:rPr>
+              <a:t>What it means</a:t>
+            </a:r>
+          </a:p>
+        </p:txBody>
+      </p:sp>
+      <p:sp>
+        <p:nvSpPr>
+          <p:cNvPr id="5" name="TextBox 4"/>
+          <p:cNvSpPr txBox="1"/>
+          <p:nvPr/>
+        </p:nvSpPr>
+        <p:spPr>
+          <a:xfrm>
+            <a:off x="6720840" y="1417320"/>
+            <a:ext cx="2514600" cy="1143000"/>
+          </a:xfrm>
+          <a:prstGeom prst="rect">
+            <a:avLst/>
+          </a:prstGeom>
+          <a:noFill/>
+        </p:spPr>
+        <p:txBody>
+          <a:bodyPr wrap="square">
+            <a:spAutoFit/>
+          </a:bodyPr>
+          <a:lstStyle/>
+          <a:p>
+            <a:pPr algn="l">
+              <a:spcAft>
+                <a:spcPts val="0"/>
+              </a:spcAft>
+            </a:pPr>
+            <a:r>
+              <a:rPr sz="1250" b="1">
+                <a:solidFill>
+                  <a:srgbClr val="2563EB"/>
+                </a:solidFill>
+                <a:latin typeface="Segoe UI"/>
+              </a:rPr>
+              <a:t>Your job</a:t>
+            </a:r>
+          </a:p>
+        </p:txBody>
+      </p:sp>
+      <p:sp>
+        <p:nvSpPr>
+          <p:cNvPr id="6" name="TextBox 5"/>
+          <p:cNvSpPr txBox="1"/>
+          <p:nvPr/>
+        </p:nvSpPr>
+        <p:spPr>
+          <a:xfrm>
+            <a:off x="9372600" y="1417320"/>
+            <a:ext cx="3063240" cy="1143000"/>
+          </a:xfrm>
+          <a:prstGeom prst="rect">
+            <a:avLst/>
+          </a:prstGeom>
+          <a:noFill/>
+        </p:spPr>
+        <p:txBody>
+          <a:bodyPr wrap="square">
+            <a:spAutoFit/>
+          </a:bodyPr>
+          <a:lstStyle/>
+          <a:p>
+            <a:pPr algn="l">
+              <a:spcAft>
+                <a:spcPts val="0"/>
+              </a:spcAft>
+            </a:pPr>
+            <a:r>
+              <a:rPr sz="1250" b="1">
+                <a:solidFill>
+                  <a:srgbClr val="2563EB"/>
+                </a:solidFill>
+                <a:latin typeface="Segoe UI"/>
+              </a:rPr>
+              <a:t>Resolve with</a:t>
+            </a:r>
+          </a:p>
+        </p:txBody>
+      </p:sp>
+      <p:sp>
+        <p:nvSpPr>
+          <p:cNvPr id="7" name="TextBox 6"/>
+          <p:cNvSpPr txBox="1"/>
+          <p:nvPr/>
+        </p:nvSpPr>
+        <p:spPr>
+          <a:xfrm>
+            <a:off x="502920" y="1984248"/>
+            <a:ext cx="2697480" cy="1143000"/>
+          </a:xfrm>
+          <a:prstGeom prst="rect">
+            <a:avLst/>
+          </a:prstGeom>
+          <a:noFill/>
+        </p:spPr>
+        <p:txBody>
+          <a:bodyPr wrap="square">
+            <a:spAutoFit/>
+          </a:bodyPr>
+          <a:lstStyle/>
+          <a:p>
+            <a:pPr algn="l">
+              <a:spcAft>
+                <a:spcPts val="200"/>
+              </a:spcAft>
+            </a:pPr>
+            <a:r>
+              <a:rPr sz="1200" b="1">
+                <a:solidFill>
+                  <a:srgbClr val="1F2937"/>
+                </a:solidFill>
+                <a:latin typeface="Segoe UI"/>
+              </a:rPr>
+              <a:t>Coverage hole</a:t>
+            </a:r>
+          </a:p>
+          <a:p>
+            <a:pPr algn="l">
+              <a:spcAft>
+                <a:spcPts val="0"/>
+              </a:spcAft>
+            </a:pPr>
+            <a:r>
+              <a:rPr sz="1100" b="0">
+                <a:solidFill>
+                  <a:srgbClr val="374151"/>
+                </a:solidFill>
+                <a:latin typeface="Segoe UI"/>
+              </a:rPr>
+              <a:t>“Is this movement really this small?”</a:t>
+            </a:r>
+          </a:p>
+        </p:txBody>
+      </p:sp>
+      <p:sp>
+        <p:nvSpPr>
+          <p:cNvPr id="8" name="TextBox 7"/>
+          <p:cNvSpPr txBox="1"/>
+          <p:nvPr/>
+        </p:nvSpPr>
+        <p:spPr>
+          <a:xfrm>
+            <a:off x="3337560" y="1984248"/>
+            <a:ext cx="3246120" cy="1143000"/>
+          </a:xfrm>
+          <a:prstGeom prst="rect">
+            <a:avLst/>
+          </a:prstGeom>
+          <a:noFill/>
+        </p:spPr>
+        <p:txBody>
+          <a:bodyPr wrap="square">
+            <a:spAutoFit/>
+          </a:bodyPr>
+          <a:lstStyle/>
+          <a:p>
+            <a:pPr algn="l">
+              <a:spcAft>
+                <a:spcPts val="200"/>
+              </a:spcAft>
+            </a:pPr>
+            <a:r>
+              <a:rPr sz="1200" b="1">
+                <a:solidFill>
+                  <a:srgbClr val="1F2937"/>
+                </a:solidFill>
+                <a:latin typeface="Segoe UI"/>
+              </a:rPr>
+              <a:t>A movement has a drawn channel but little or no counted volume — either genuinely tiny, or the applied bank missed it.</a:t>
+            </a:r>
+          </a:p>
+        </p:txBody>
+      </p:sp>
+      <p:sp>
+        <p:nvSpPr>
+          <p:cNvPr id="9" name="TextBox 8"/>
+          <p:cNvSpPr txBox="1"/>
+          <p:nvPr/>
+        </p:nvSpPr>
+        <p:spPr>
+          <a:xfrm>
+            <a:off x="6720840" y="1984248"/>
+            <a:ext cx="2514600" cy="1143000"/>
+          </a:xfrm>
+          <a:prstGeom prst="rect">
+            <a:avLst/>
+          </a:prstGeom>
+          <a:noFill/>
+        </p:spPr>
+        <p:txBody>
+          <a:bodyPr wrap="square">
+            <a:spAutoFit/>
+          </a:bodyPr>
+          <a:lstStyle/>
+          <a:p>
+            <a:pPr algn="l">
+              <a:spcAft>
+                <a:spcPts val="200"/>
+              </a:spcAft>
+            </a:pPr>
+            <a:r>
+              <a:rPr sz="1200" b="1">
+                <a:solidFill>
+                  <a:srgbClr val="1F2937"/>
+                </a:solidFill>
+                <a:latin typeface="Segoe UI"/>
+              </a:rPr>
+              <a:t>Scrub the interval; decide whether traffic is really that light.</a:t>
+            </a:r>
+          </a:p>
+        </p:txBody>
+      </p:sp>
+      <p:sp>
+        <p:nvSpPr>
+          <p:cNvPr id="10" name="TextBox 9"/>
+          <p:cNvSpPr txBox="1"/>
+          <p:nvPr/>
+        </p:nvSpPr>
+        <p:spPr>
+          <a:xfrm>
+            <a:off x="9372600" y="1984248"/>
+            <a:ext cx="3063240" cy="1143000"/>
+          </a:xfrm>
+          <a:prstGeom prst="rect">
+            <a:avLst/>
+          </a:prstGeom>
+          <a:noFill/>
+        </p:spPr>
+        <p:txBody>
+          <a:bodyPr wrap="square">
+            <a:spAutoFit/>
+          </a:bodyPr>
+          <a:lstStyle/>
+          <a:p>
+            <a:pPr algn="l">
+              <a:spcAft>
+                <a:spcPts val="200"/>
+              </a:spcAft>
+            </a:pPr>
+            <a:r>
+              <a:rPr sz="1200" b="1">
+                <a:solidFill>
+                  <a:srgbClr val="1F2937"/>
+                </a:solidFill>
+                <a:latin typeface="Segoe UI"/>
+              </a:rPr>
+              <a:t>D Dismiss if real low volume · A add any missed vehicles · rebuild bank if systemic</a:t>
+            </a:r>
+          </a:p>
+        </p:txBody>
+      </p:sp>
+      <p:sp>
+        <p:nvSpPr>
+          <p:cNvPr id="11" name="TextBox 10"/>
+          <p:cNvSpPr txBox="1"/>
+          <p:nvPr/>
+        </p:nvSpPr>
+        <p:spPr>
+          <a:xfrm>
+            <a:off x="502920" y="3465576"/>
+            <a:ext cx="2697480" cy="1143000"/>
+          </a:xfrm>
+          <a:prstGeom prst="rect">
+            <a:avLst/>
+          </a:prstGeom>
+          <a:noFill/>
+        </p:spPr>
+        <p:txBody>
+          <a:bodyPr wrap="square">
+            <a:spAutoFit/>
+          </a:bodyPr>
+          <a:lstStyle/>
+          <a:p>
+            <a:pPr algn="l">
+              <a:spcAft>
+                <a:spcPts val="200"/>
+              </a:spcAft>
+            </a:pPr>
+            <a:r>
+              <a:rPr sz="1200" b="1">
+                <a:solidFill>
+                  <a:srgbClr val="1F2937"/>
+                </a:solidFill>
+                <a:latin typeface="Segoe UI"/>
+              </a:rPr>
+              <a:t>Interval undercount</a:t>
+            </a:r>
+          </a:p>
+          <a:p>
+            <a:pPr algn="l">
+              <a:spcAft>
+                <a:spcPts val="0"/>
+              </a:spcAft>
+            </a:pPr>
+            <a:r>
+              <a:rPr sz="1100" b="0">
+                <a:solidFill>
+                  <a:srgbClr val="374151"/>
+                </a:solidFill>
+                <a:latin typeface="Segoe UI"/>
+              </a:rPr>
+              <a:t>“Did the system miss vehicles here?”</a:t>
+            </a:r>
+          </a:p>
+        </p:txBody>
+      </p:sp>
+      <p:sp>
+        <p:nvSpPr>
+          <p:cNvPr id="12" name="TextBox 11"/>
+          <p:cNvSpPr txBox="1"/>
+          <p:nvPr/>
+        </p:nvSpPr>
+        <p:spPr>
+          <a:xfrm>
+            <a:off x="3337560" y="3465576"/>
+            <a:ext cx="3246120" cy="1143000"/>
+          </a:xfrm>
+          <a:prstGeom prst="rect">
+            <a:avLst/>
+          </a:prstGeom>
+          <a:noFill/>
+        </p:spPr>
+        <p:txBody>
+          <a:bodyPr wrap="square">
+            <a:spAutoFit/>
+          </a:bodyPr>
+          <a:lstStyle/>
+          <a:p>
+            <a:pPr algn="l">
+              <a:spcAft>
+                <a:spcPts val="200"/>
+              </a:spcAft>
+            </a:pPr>
+            <a:r>
+              <a:rPr sz="1200" b="1">
+                <a:solidFill>
+                  <a:srgbClr val="1F2937"/>
+                </a:solidFill>
+                <a:latin typeface="Segoe UI"/>
+              </a:rPr>
+              <a:t>A corridor-conservation gap localized to one 15-min bin (e.g. “Sbound short by 176 this bin”).</a:t>
+            </a:r>
+          </a:p>
+        </p:txBody>
+      </p:sp>
+      <p:sp>
+        <p:nvSpPr>
+          <p:cNvPr id="13" name="TextBox 12"/>
+          <p:cNvSpPr txBox="1"/>
+          <p:nvPr/>
+        </p:nvSpPr>
+        <p:spPr>
+          <a:xfrm>
+            <a:off x="6720840" y="3465576"/>
+            <a:ext cx="2514600" cy="1143000"/>
+          </a:xfrm>
+          <a:prstGeom prst="rect">
+            <a:avLst/>
+          </a:prstGeom>
+          <a:noFill/>
+        </p:spPr>
+        <p:txBody>
+          <a:bodyPr wrap="square">
+            <a:spAutoFit/>
+          </a:bodyPr>
+          <a:lstStyle/>
+          <a:p>
+            <a:pPr algn="l">
+              <a:spcAft>
+                <a:spcPts val="200"/>
+              </a:spcAft>
+            </a:pPr>
+            <a:r>
+              <a:rPr sz="1200" b="1">
+                <a:solidFill>
+                  <a:srgbClr val="1F2937"/>
+                </a:solidFill>
+                <a:latin typeface="Segoe UI"/>
+              </a:rPr>
+              <a:t>Watch the flagged approach in that window; add what the tracker missed.</a:t>
+            </a:r>
+          </a:p>
+        </p:txBody>
+      </p:sp>
+      <p:sp>
+        <p:nvSpPr>
+          <p:cNvPr id="14" name="TextBox 13"/>
+          <p:cNvSpPr txBox="1"/>
+          <p:nvPr/>
+        </p:nvSpPr>
+        <p:spPr>
+          <a:xfrm>
+            <a:off x="9372600" y="3465576"/>
+            <a:ext cx="3063240" cy="1143000"/>
+          </a:xfrm>
+          <a:prstGeom prst="rect">
+            <a:avLst/>
+          </a:prstGeom>
+          <a:noFill/>
+        </p:spPr>
+        <p:txBody>
+          <a:bodyPr wrap="square">
+            <a:spAutoFit/>
+          </a:bodyPr>
+          <a:lstStyle/>
+          <a:p>
+            <a:pPr algn="l">
+              <a:spcAft>
+                <a:spcPts val="200"/>
+              </a:spcAft>
+            </a:pPr>
+            <a:r>
+              <a:rPr sz="1200" b="1">
+                <a:solidFill>
+                  <a:srgbClr val="1F2937"/>
+                </a:solidFill>
+                <a:latin typeface="Segoe UI"/>
+              </a:rPr>
+              <a:t>A Add missed for each vehicle · Enter when the bin looks right</a:t>
+            </a:r>
+          </a:p>
+        </p:txBody>
+      </p:sp>
+      <p:sp>
+        <p:nvSpPr>
+          <p:cNvPr id="15" name="TextBox 14"/>
+          <p:cNvSpPr txBox="1"/>
+          <p:nvPr/>
+        </p:nvSpPr>
+        <p:spPr>
+          <a:xfrm>
+            <a:off x="502920" y="4946904"/>
+            <a:ext cx="2697480" cy="1143000"/>
+          </a:xfrm>
+          <a:prstGeom prst="rect">
+            <a:avLst/>
+          </a:prstGeom>
+          <a:noFill/>
+        </p:spPr>
+        <p:txBody>
+          <a:bodyPr wrap="square">
+            <a:spAutoFit/>
+          </a:bodyPr>
+          <a:lstStyle/>
+          <a:p>
+            <a:pPr algn="l">
+              <a:spcAft>
+                <a:spcPts val="200"/>
+              </a:spcAft>
+            </a:pPr>
+            <a:r>
+              <a:rPr sz="1200" b="1">
+                <a:solidFill>
+                  <a:srgbClr val="1F2937"/>
+                </a:solidFill>
+                <a:latin typeface="Segoe UI"/>
+              </a:rPr>
+              <a:t>Echo suspect</a:t>
+            </a:r>
+          </a:p>
+          <a:p>
+            <a:pPr algn="l">
+              <a:spcAft>
+                <a:spcPts val="0"/>
+              </a:spcAft>
+            </a:pPr>
+            <a:r>
+              <a:rPr sz="1100" b="0">
+                <a:solidFill>
+                  <a:srgbClr val="374151"/>
+                </a:solidFill>
+                <a:latin typeface="Segoe UI"/>
+              </a:rPr>
+              <a:t>“counts repeat the same vehicle”</a:t>
+            </a:r>
+          </a:p>
+        </p:txBody>
+      </p:sp>
+      <p:sp>
+        <p:nvSpPr>
+          <p:cNvPr id="16" name="TextBox 15"/>
+          <p:cNvSpPr txBox="1"/>
+          <p:nvPr/>
+        </p:nvSpPr>
+        <p:spPr>
+          <a:xfrm>
+            <a:off x="3337560" y="4946904"/>
+            <a:ext cx="3246120" cy="1143000"/>
+          </a:xfrm>
+          <a:prstGeom prst="rect">
+            <a:avLst/>
+          </a:prstGeom>
+          <a:noFill/>
+        </p:spPr>
+        <p:txBody>
+          <a:bodyPr wrap="square">
+            <a:spAutoFit/>
+          </a:bodyPr>
+          <a:lstStyle/>
+          <a:p>
+            <a:pPr algn="l">
+              <a:spcAft>
+                <a:spcPts val="200"/>
+              </a:spcAft>
+            </a:pPr>
+            <a:r>
+              <a:rPr sz="1200" b="1">
+                <a:solidFill>
+                  <a:srgbClr val="1F2937"/>
+                </a:solidFill>
+                <a:latin typeface="Segoe UI"/>
+              </a:rPr>
+              <a:t>Track-fragment echoes make a movement read HIGHER than reality (e.g. ~101 repeats this day).</a:t>
+            </a:r>
+          </a:p>
+        </p:txBody>
+      </p:sp>
+      <p:sp>
+        <p:nvSpPr>
+          <p:cNvPr id="17" name="TextBox 16"/>
+          <p:cNvSpPr txBox="1"/>
+          <p:nvPr/>
+        </p:nvSpPr>
+        <p:spPr>
+          <a:xfrm>
+            <a:off x="6720840" y="4946904"/>
+            <a:ext cx="2514600" cy="1143000"/>
+          </a:xfrm>
+          <a:prstGeom prst="rect">
+            <a:avLst/>
+          </a:prstGeom>
+          <a:noFill/>
+        </p:spPr>
+        <p:txBody>
+          <a:bodyPr wrap="square">
+            <a:spAutoFit/>
+          </a:bodyPr>
+          <a:lstStyle/>
+          <a:p>
+            <a:pPr algn="l">
+              <a:spcAft>
+                <a:spcPts val="200"/>
+              </a:spcAft>
+            </a:pPr>
+            <a:r>
+              <a:rPr sz="1200" b="1">
+                <a:solidFill>
+                  <a:srgbClr val="1F2937"/>
+                </a:solidFill>
+                <a:latin typeface="Segoe UI"/>
+              </a:rPr>
+              <a:t>Review the failing bins; remove duplicates.</a:t>
+            </a:r>
+          </a:p>
+        </p:txBody>
+      </p:sp>
+      <p:sp>
+        <p:nvSpPr>
+          <p:cNvPr id="18" name="TextBox 17"/>
+          <p:cNvSpPr txBox="1"/>
+          <p:nvPr/>
+        </p:nvSpPr>
+        <p:spPr>
+          <a:xfrm>
+            <a:off x="9372600" y="4946904"/>
+            <a:ext cx="3063240" cy="1143000"/>
+          </a:xfrm>
+          <a:prstGeom prst="rect">
+            <a:avLst/>
+          </a:prstGeom>
+          <a:noFill/>
+        </p:spPr>
+        <p:txBody>
+          <a:bodyPr wrap="square">
+            <a:spAutoFit/>
+          </a:bodyPr>
+          <a:lstStyle/>
+          <a:p>
+            <a:pPr algn="l">
+              <a:spcAft>
+                <a:spcPts val="200"/>
+              </a:spcAft>
+            </a:pPr>
+            <a:r>
+              <a:rPr sz="1200" b="1">
+                <a:solidFill>
+                  <a:srgbClr val="1F2937"/>
+                </a:solidFill>
+                <a:latin typeface="Segoe UI"/>
+              </a:rPr>
+              <a:t>Del reject the duplicate events · Enter when clean</a:t>
+            </a:r>
+          </a:p>
+        </p:txBody>
+      </p:sp>
+      <p:sp>
+        <p:nvSpPr>
+          <p:cNvPr id="19" name="TextBox 18"/>
+          <p:cNvSpPr txBox="1"/>
+          <p:nvPr/>
+        </p:nvSpPr>
+        <p:spPr>
+          <a:xfrm>
+            <a:off x="502920" y="6263640"/>
+            <a:ext cx="11247120" cy="457200"/>
+          </a:xfrm>
+          <a:prstGeom prst="rect">
+            <a:avLst/>
+          </a:prstGeom>
+          <a:noFill/>
+        </p:spPr>
+        <p:txBody>
+          <a:bodyPr wrap="square">
+            <a:spAutoFit/>
+          </a:bodyPr>
+          <a:lstStyle/>
+          <a:p>
+            <a:pPr algn="l">
+              <a:spcAft>
+                <a:spcPts val="0"/>
+              </a:spcAft>
+            </a:pPr>
+            <a:r>
+              <a:rPr sz="1200" b="0">
+                <a:solidFill>
+                  <a:srgbClr val="6B7280"/>
+                </a:solidFill>
+                <a:latin typeface="Segoe UI"/>
+              </a:rPr>
+              <a:t>Skip (→) defers a card without resolving — it stays in the queue. Z undoes any resolution. “.” jumps to the next card in the same group; B resolves the whole group at once.</a:t>
             </a:r>
           </a:p>
         </p:txBody>
@@ -5213,7 +6378,7 @@
                 </a:solidFill>
                 <a:latin typeface="Segoe UI"/>
               </a:rPr>
-              <a:t>one card per intersection × date, built from the video labels</a:t>
+              <a:t>one card per intersection × date</a:t>
             </a:r>
           </a:p>
           <a:p>
@@ -5247,7 +6412,7 @@
                 </a:solidFill>
                 <a:latin typeface="Segoe UI"/>
               </a:rPr>
-              <a:t>name, number of legs (3 for T-junctions), cameras, trims</a:t>
+              <a:t>name, number of legs (3 for T-junctions), cameras, trims, two-pass readiness</a:t>
             </a:r>
           </a:p>
           <a:p>
@@ -5281,7 +6446,7 @@
                 </a:solidFill>
                 <a:latin typeface="Segoe UI"/>
               </a:rPr>
-              <a:t>legs → channels → road paths, then Save calibration</a:t>
+              <a:t>legs → channels → road paths → Save</a:t>
             </a:r>
           </a:p>
           <a:p>
@@ -5315,7 +6480,7 @@
                 </a:solidFill>
                 <a:latin typeface="Segoe UI"/>
               </a:rPr>
-              <a:t>the wall-clock windows to count (e.g. 07:00–09:00)</a:t>
+              <a:t>the wall-clock windows to count</a:t>
             </a:r>
           </a:p>
           <a:p>
@@ -5349,7 +6514,7 @@
                 </a:solidFill>
                 <a:latin typeface="Segoe UI"/>
               </a:rPr>
-              <a:t>pick a mode and let it run — full days usually run overnight</a:t>
+              <a:t>pick a mode; full days run overnight</a:t>
             </a:r>
           </a:p>
           <a:p>
@@ -5383,7 +6548,7 @@
                 </a:solidFill>
                 <a:latin typeface="Segoe UI"/>
               </a:rPr>
-              <a:t>corridor checks, spot count, and the flag review cards</a:t>
+              <a:t>corridor checks, spot count, flag cards — keyboard-first</a:t>
             </a:r>
           </a:p>
           <a:p>
@@ -5417,7 +6582,1534 @@
                 </a:solidFill>
                 <a:latin typeface="Segoe UI"/>
               </a:rPr>
-              <a:t>Excel / PDF buttons on the intersection card</a:t>
+              <a:t>Excel / PDF from the card; a 5-sheet TMC workbook</a:t>
+            </a:r>
+          </a:p>
+        </p:txBody>
+      </p:sp>
+    </p:spTree>
+  </p:cSld>
+  <p:clrMapOvr>
+    <a:masterClrMapping/>
+  </p:clrMapOvr>
+</p:sld>
+</file>
+
+<file path=ppt/slides/slide20.xml><?xml version="1.0" encoding="utf-8"?>
+<p:sld xmlns:a="http://schemas.openxmlformats.org/drawingml/2006/main" xmlns:p="http://schemas.openxmlformats.org/presentationml/2006/main" xmlns:r="http://schemas.openxmlformats.org/officeDocument/2006/relationships">
+  <p:cSld>
+    <p:spTree>
+      <p:nvGrpSpPr>
+        <p:cNvPr id="1" name=""/>
+        <p:cNvGrpSpPr/>
+        <p:nvPr/>
+      </p:nvGrpSpPr>
+      <p:grpSpPr/>
+      <p:sp>
+        <p:nvSpPr>
+          <p:cNvPr id="2" name="TextBox 1"/>
+          <p:cNvSpPr txBox="1"/>
+          <p:nvPr/>
+        </p:nvSpPr>
+        <p:spPr>
+          <a:xfrm>
+            <a:off x="502920" y="256032"/>
+            <a:ext cx="11247120" cy="1005840"/>
+          </a:xfrm>
+          <a:prstGeom prst="rect">
+            <a:avLst/>
+          </a:prstGeom>
+          <a:noFill/>
+        </p:spPr>
+        <p:txBody>
+          <a:bodyPr wrap="square">
+            <a:spAutoFit/>
+          </a:bodyPr>
+          <a:lstStyle/>
+          <a:p>
+            <a:pPr algn="l">
+              <a:spcAft>
+                <a:spcPts val="200"/>
+              </a:spcAft>
+            </a:pPr>
+            <a:r>
+              <a:rPr sz="1200" b="1">
+                <a:solidFill>
+                  <a:srgbClr val="2563EB"/>
+                </a:solidFill>
+                <a:latin typeface="Segoe UI"/>
+              </a:rPr>
+              <a:t>STEP 8B · ▶ IN MOTION</a:t>
+            </a:r>
+          </a:p>
+          <a:p>
+            <a:pPr algn="l">
+              <a:spcAft>
+                <a:spcPts val="0"/>
+              </a:spcAft>
+            </a:pPr>
+            <a:r>
+              <a:rPr sz="2600" b="1">
+                <a:solidFill>
+                  <a:srgbClr val="1F2937"/>
+                </a:solidFill>
+                <a:latin typeface="Segoe UI"/>
+              </a:rPr>
+              <a:t>Working the queue, keyboard-first</a:t>
+            </a:r>
+          </a:p>
+        </p:txBody>
+      </p:sp>
+      <p:sp>
+        <p:nvSpPr>
+          <p:cNvPr id="3" name="TextBox 2"/>
+          <p:cNvSpPr txBox="1"/>
+          <p:nvPr/>
+        </p:nvSpPr>
+        <p:spPr>
+          <a:xfrm>
+            <a:off x="502920" y="1417320"/>
+            <a:ext cx="3977639" cy="5120640"/>
+          </a:xfrm>
+          <a:prstGeom prst="rect">
+            <a:avLst/>
+          </a:prstGeom>
+          <a:noFill/>
+        </p:spPr>
+        <p:txBody>
+          <a:bodyPr wrap="square">
+            <a:spAutoFit/>
+          </a:bodyPr>
+          <a:lstStyle/>
+          <a:p>
+            <a:pPr algn="l">
+              <a:spcAft>
+                <a:spcPts val="400"/>
+              </a:spcAft>
+            </a:pPr>
+            <a:r>
+              <a:rPr sz="1400" b="1">
+                <a:solidFill>
+                  <a:srgbClr val="1F2937"/>
+                </a:solidFill>
+                <a:latin typeface="Segoe UI"/>
+              </a:rPr>
+              <a:t>The rhythm</a:t>
+            </a:r>
+          </a:p>
+          <a:p>
+            <a:pPr algn="l">
+              <a:spcAft>
+                <a:spcPts val="700"/>
+              </a:spcAft>
+            </a:pPr>
+            <a:r>
+              <a:rPr sz="1350" b="0">
+                <a:solidFill>
+                  <a:srgbClr val="374151"/>
+                </a:solidFill>
+                <a:latin typeface="Segoe UI"/>
+              </a:rPr>
+              <a:t>•  Read the question and the evidence line.</a:t>
+            </a:r>
+          </a:p>
+          <a:p>
+            <a:pPr algn="l">
+              <a:spcAft>
+                <a:spcPts val="700"/>
+              </a:spcAft>
+            </a:pPr>
+            <a:r>
+              <a:rPr sz="1350" b="0">
+                <a:solidFill>
+                  <a:srgbClr val="374151"/>
+                </a:solidFill>
+                <a:latin typeface="Segoe UI"/>
+              </a:rPr>
+              <a:t>•  Scrub the interval — watch the flagged approach only.</a:t>
+            </a:r>
+          </a:p>
+          <a:p>
+            <a:pPr algn="l">
+              <a:spcAft>
+                <a:spcPts val="700"/>
+              </a:spcAft>
+            </a:pPr>
+            <a:r>
+              <a:rPr sz="1350" b="0">
+                <a:solidFill>
+                  <a:srgbClr val="374151"/>
+                </a:solidFill>
+                <a:latin typeface="Segoe UI"/>
+              </a:rPr>
+              <a:t>•  Enter accepts (“looks counted”) · A adds a missed vehicle · D dismisses · → skips for later.</a:t>
+            </a:r>
+          </a:p>
+          <a:p>
+            <a:pPr algn="l">
+              <a:spcAft>
+                <a:spcPts val="700"/>
+              </a:spcAft>
+            </a:pPr>
+            <a:r>
+              <a:rPr sz="1350" b="0">
+                <a:solidFill>
+                  <a:srgbClr val="374151"/>
+                </a:solidFill>
+                <a:latin typeface="Segoe UI"/>
+              </a:rPr>
+              <a:t>•  The queue counter drops as you resolve; Z undoes anything, immediately.</a:t>
+            </a:r>
+          </a:p>
+          <a:p>
+            <a:pPr algn="l">
+              <a:spcAft>
+                <a:spcPts val="600"/>
+              </a:spcAft>
+            </a:pPr>
+            <a:r>
+              <a:rPr sz="1250" b="1">
+                <a:solidFill>
+                  <a:srgbClr val="0E7A4E"/>
+                </a:solidFill>
+                <a:latin typeface="Segoe UI"/>
+              </a:rPr>
+              <a:t>This demo resolved a card (286 → 285) and undid it (back to 286) — the database was verified unchanged.</a:t>
+            </a:r>
+          </a:p>
+        </p:txBody>
+      </p:sp>
+      <p:pic>
+        <p:nvPicPr>
+          <p:cNvPr id="4" name="Picture 3" descr="gif_05_flag_review.gif"/>
+          <p:cNvPicPr>
+            <a:picLocks noChangeAspect="1"/>
+          </p:cNvPicPr>
+          <p:nvPr/>
+        </p:nvPicPr>
+        <p:blipFill>
+          <a:blip r:embed="rId2"/>
+          <a:stretch>
+            <a:fillRect/>
+          </a:stretch>
+        </p:blipFill>
+        <p:spPr>
+          <a:xfrm>
+            <a:off x="4617720" y="1481328"/>
+            <a:ext cx="7406640" cy="4167918"/>
+          </a:xfrm>
+          <a:prstGeom prst="rect">
+            <a:avLst/>
+          </a:prstGeom>
+          <a:ln w="12700">
+            <a:solidFill>
+              <a:srgbClr val="D1D5DB"/>
+            </a:solidFill>
+          </a:ln>
+        </p:spPr>
+      </p:pic>
+      <p:sp>
+        <p:nvSpPr>
+          <p:cNvPr id="5" name="TextBox 4"/>
+          <p:cNvSpPr txBox="1"/>
+          <p:nvPr/>
+        </p:nvSpPr>
+        <p:spPr>
+          <a:xfrm>
+            <a:off x="4617720" y="5806440"/>
+            <a:ext cx="7406640" cy="365760"/>
+          </a:xfrm>
+          <a:prstGeom prst="rect">
+            <a:avLst/>
+          </a:prstGeom>
+          <a:noFill/>
+        </p:spPr>
+        <p:txBody>
+          <a:bodyPr wrap="square">
+            <a:spAutoFit/>
+          </a:bodyPr>
+          <a:lstStyle/>
+          <a:p>
+            <a:pPr algn="l">
+              <a:spcAft>
+                <a:spcPts val="0"/>
+              </a:spcAft>
+            </a:pPr>
+            <a:r>
+              <a:rPr sz="1050" b="0">
+                <a:solidFill>
+                  <a:srgbClr val="6B7280"/>
+                </a:solidFill>
+                <a:latin typeface="Segoe UI"/>
+              </a:rPr>
+              <a:t>▶ Three cards, a scrub, a resolve, and the undo.</a:t>
+            </a:r>
+          </a:p>
+        </p:txBody>
+      </p:sp>
+    </p:spTree>
+  </p:cSld>
+  <p:clrMapOvr>
+    <a:masterClrMapping/>
+  </p:clrMapOvr>
+</p:sld>
+</file>
+
+<file path=ppt/slides/slide21.xml><?xml version="1.0" encoding="utf-8"?>
+<p:sld xmlns:a="http://schemas.openxmlformats.org/drawingml/2006/main" xmlns:p="http://schemas.openxmlformats.org/presentationml/2006/main" xmlns:r="http://schemas.openxmlformats.org/officeDocument/2006/relationships">
+  <p:cSld>
+    <p:spTree>
+      <p:nvGrpSpPr>
+        <p:cNvPr id="1" name=""/>
+        <p:cNvGrpSpPr/>
+        <p:nvPr/>
+      </p:nvGrpSpPr>
+      <p:grpSpPr/>
+      <p:sp>
+        <p:nvSpPr>
+          <p:cNvPr id="2" name="TextBox 1"/>
+          <p:cNvSpPr txBox="1"/>
+          <p:nvPr/>
+        </p:nvSpPr>
+        <p:spPr>
+          <a:xfrm>
+            <a:off x="502920" y="256032"/>
+            <a:ext cx="11247120" cy="1005840"/>
+          </a:xfrm>
+          <a:prstGeom prst="rect">
+            <a:avLst/>
+          </a:prstGeom>
+          <a:noFill/>
+        </p:spPr>
+        <p:txBody>
+          <a:bodyPr wrap="square">
+            <a:spAutoFit/>
+          </a:bodyPr>
+          <a:lstStyle/>
+          <a:p>
+            <a:pPr algn="l">
+              <a:spcAft>
+                <a:spcPts val="200"/>
+              </a:spcAft>
+            </a:pPr>
+            <a:r>
+              <a:rPr sz="1200" b="1">
+                <a:solidFill>
+                  <a:srgbClr val="2563EB"/>
+                </a:solidFill>
+                <a:latin typeface="Segoe UI"/>
+              </a:rPr>
+              <a:t>STEP 8C · THE GATE PANEL</a:t>
+            </a:r>
+          </a:p>
+          <a:p>
+            <a:pPr algn="l">
+              <a:spcAft>
+                <a:spcPts val="0"/>
+              </a:spcAft>
+            </a:pPr>
+            <a:r>
+              <a:rPr sz="2600" b="1">
+                <a:solidFill>
+                  <a:srgbClr val="1F2937"/>
+                </a:solidFill>
+                <a:latin typeface="Segoe UI"/>
+              </a:rPr>
+              <a:t>What flags can clear — and what they can't</a:t>
+            </a:r>
+          </a:p>
+        </p:txBody>
+      </p:sp>
+      <p:sp>
+        <p:nvSpPr>
+          <p:cNvPr id="3" name="TextBox 2"/>
+          <p:cNvSpPr txBox="1"/>
+          <p:nvPr/>
+        </p:nvSpPr>
+        <p:spPr>
+          <a:xfrm>
+            <a:off x="502920" y="1417320"/>
+            <a:ext cx="6400800" cy="5120640"/>
+          </a:xfrm>
+          <a:prstGeom prst="rect">
+            <a:avLst/>
+          </a:prstGeom>
+          <a:noFill/>
+        </p:spPr>
+        <p:txBody>
+          <a:bodyPr wrap="square">
+            <a:spAutoFit/>
+          </a:bodyPr>
+          <a:lstStyle/>
+          <a:p>
+            <a:pPr algn="l">
+              <a:spcAft>
+                <a:spcPts val="400"/>
+              </a:spcAft>
+            </a:pPr>
+            <a:r>
+              <a:rPr sz="1400" b="1">
+                <a:solidFill>
+                  <a:srgbClr val="1F2937"/>
+                </a:solidFill>
+                <a:latin typeface="Segoe UI"/>
+              </a:rPr>
+              <a:t>The sidebar keeps score</a:t>
+            </a:r>
+          </a:p>
+          <a:p>
+            <a:pPr algn="l">
+              <a:spcAft>
+                <a:spcPts val="700"/>
+              </a:spcAft>
+            </a:pPr>
+            <a:r>
+              <a:rPr sz="1350" b="0">
+                <a:solidFill>
+                  <a:srgbClr val="374151"/>
+                </a:solidFill>
+                <a:latin typeface="Segoe UI"/>
+              </a:rPr>
+              <a:t>•  Live count: the running total as you work.</a:t>
+            </a:r>
+          </a:p>
+          <a:p>
+            <a:pPr algn="l">
+              <a:spcAft>
+                <a:spcPts val="700"/>
+              </a:spcAft>
+            </a:pPr>
+            <a:r>
+              <a:rPr sz="1350" b="0">
+                <a:solidFill>
+                  <a:srgbClr val="374151"/>
+                </a:solidFill>
+                <a:latin typeface="Segoe UI"/>
+              </a:rPr>
+              <a:t>•  Remaining work: cards left and their estimated vehicle impact (here: ~4,027 veh to a clean queue).</a:t>
+            </a:r>
+          </a:p>
+          <a:p>
+            <a:pPr algn="l">
+              <a:spcAft>
+                <a:spcPts val="700"/>
+              </a:spcAft>
+            </a:pPr>
+            <a:r>
+              <a:rPr sz="1350" b="0">
+                <a:solidFill>
+                  <a:srgbClr val="374151"/>
+                </a:solidFill>
+                <a:latin typeface="Segoe UI"/>
+              </a:rPr>
+              <a:t>•  Gate list: each export check with its state and the route to fix it.</a:t>
+            </a:r>
+          </a:p>
+          <a:p>
+            <a:pPr algn="l">
+              <a:spcAft>
+                <a:spcPts val="600"/>
+              </a:spcAft>
+            </a:pPr>
+            <a:r>
+              <a:rPr sz="1250" b="1">
+                <a:solidFill>
+                  <a:srgbClr val="B45309"/>
+                </a:solidFill>
+                <a:latin typeface="Segoe UI"/>
+              </a:rPr>
+              <a:t>⚠  corridor consistency FAIL points at cross-intersection conservation — investigate on the QA tab (spot count the implicated link); working flag cards will NOT clear it.</a:t>
+            </a:r>
+          </a:p>
+          <a:p>
+            <a:pPr algn="l">
+              <a:spcAft>
+                <a:spcPts val="700"/>
+              </a:spcAft>
+            </a:pPr>
+            <a:r>
+              <a:rPr sz="1350" b="0">
+                <a:solidFill>
+                  <a:srgbClr val="374151"/>
+                </a:solidFill>
+                <a:latin typeface="Segoe UI"/>
+              </a:rPr>
+              <a:t>•  review flags REVIEW clears exactly by working the cards below.</a:t>
+            </a:r>
+          </a:p>
+          <a:p>
+            <a:pPr algn="l">
+              <a:spcAft>
+                <a:spcPts val="700"/>
+              </a:spcAft>
+            </a:pPr>
+            <a:r>
+              <a:rPr sz="1350" b="0">
+                <a:solidFill>
+                  <a:srgbClr val="374151"/>
+                </a:solidFill>
+                <a:latin typeface="Segoe UI"/>
+              </a:rPr>
+              <a:t>•  “Rebuild queue” re-derives the cards after big changes.</a:t>
+            </a:r>
+          </a:p>
+        </p:txBody>
+      </p:sp>
+      <p:pic>
+        <p:nvPicPr>
+          <p:cNvPr id="4" name="Picture 3" descr="zoom_flag_sidebar.png"/>
+          <p:cNvPicPr>
+            <a:picLocks noChangeAspect="1"/>
+          </p:cNvPicPr>
+          <p:nvPr/>
+        </p:nvPicPr>
+        <p:blipFill>
+          <a:blip r:embed="rId2"/>
+          <a:stretch>
+            <a:fillRect/>
+          </a:stretch>
+        </p:blipFill>
+        <p:spPr>
+          <a:xfrm>
+            <a:off x="7315200" y="1481328"/>
+            <a:ext cx="4206240" cy="5552237"/>
+          </a:xfrm>
+          <a:prstGeom prst="rect">
+            <a:avLst/>
+          </a:prstGeom>
+          <a:ln w="12700">
+            <a:solidFill>
+              <a:srgbClr val="D1D5DB"/>
+            </a:solidFill>
+          </a:ln>
+        </p:spPr>
+      </p:pic>
+      <p:sp>
+        <p:nvSpPr>
+          <p:cNvPr id="5" name="TextBox 4"/>
+          <p:cNvSpPr txBox="1"/>
+          <p:nvPr/>
+        </p:nvSpPr>
+        <p:spPr>
+          <a:xfrm>
+            <a:off x="7315200" y="5806440"/>
+            <a:ext cx="4206240" cy="365760"/>
+          </a:xfrm>
+          <a:prstGeom prst="rect">
+            <a:avLst/>
+          </a:prstGeom>
+          <a:noFill/>
+        </p:spPr>
+        <p:txBody>
+          <a:bodyPr wrap="square">
+            <a:spAutoFit/>
+          </a:bodyPr>
+          <a:lstStyle/>
+          <a:p>
+            <a:pPr algn="l">
+              <a:spcAft>
+                <a:spcPts val="0"/>
+              </a:spcAft>
+            </a:pPr>
+            <a:r>
+              <a:rPr sz="1050" b="0">
+                <a:solidFill>
+                  <a:srgbClr val="6B7280"/>
+                </a:solidFill>
+                <a:latin typeface="Segoe UI"/>
+              </a:rPr>
+              <a:t>The gate panel: FAIL / INFO / REVIEW with fix routes.</a:t>
+            </a:r>
+          </a:p>
+        </p:txBody>
+      </p:sp>
+    </p:spTree>
+  </p:cSld>
+  <p:clrMapOvr>
+    <a:masterClrMapping/>
+  </p:clrMapOvr>
+</p:sld>
+</file>
+
+<file path=ppt/slides/slide22.xml><?xml version="1.0" encoding="utf-8"?>
+<p:sld xmlns:a="http://schemas.openxmlformats.org/drawingml/2006/main" xmlns:p="http://schemas.openxmlformats.org/presentationml/2006/main" xmlns:r="http://schemas.openxmlformats.org/officeDocument/2006/relationships">
+  <p:cSld>
+    <p:spTree>
+      <p:nvGrpSpPr>
+        <p:cNvPr id="1" name=""/>
+        <p:cNvGrpSpPr/>
+        <p:nvPr/>
+      </p:nvGrpSpPr>
+      <p:grpSpPr/>
+      <p:sp>
+        <p:nvSpPr>
+          <p:cNvPr id="2" name="TextBox 1"/>
+          <p:cNvSpPr txBox="1"/>
+          <p:nvPr/>
+        </p:nvSpPr>
+        <p:spPr>
+          <a:xfrm>
+            <a:off x="502920" y="256032"/>
+            <a:ext cx="11247120" cy="1005840"/>
+          </a:xfrm>
+          <a:prstGeom prst="rect">
+            <a:avLst/>
+          </a:prstGeom>
+          <a:noFill/>
+        </p:spPr>
+        <p:txBody>
+          <a:bodyPr wrap="square">
+            <a:spAutoFit/>
+          </a:bodyPr>
+          <a:lstStyle/>
+          <a:p>
+            <a:pPr algn="l">
+              <a:spcAft>
+                <a:spcPts val="200"/>
+              </a:spcAft>
+            </a:pPr>
+            <a:r>
+              <a:rPr sz="1200" b="1">
+                <a:solidFill>
+                  <a:srgbClr val="2563EB"/>
+                </a:solidFill>
+                <a:latin typeface="Segoe UI"/>
+              </a:rPr>
+              <a:t>STEP 9 · ▶ EXPORT</a:t>
+            </a:r>
+          </a:p>
+          <a:p>
+            <a:pPr algn="l">
+              <a:spcAft>
+                <a:spcPts val="0"/>
+              </a:spcAft>
+            </a:pPr>
+            <a:r>
+              <a:rPr sz="2600" b="1">
+                <a:solidFill>
+                  <a:srgbClr val="1F2937"/>
+                </a:solidFill>
+                <a:latin typeface="Segoe UI"/>
+              </a:rPr>
+              <a:t>Excel and PDF, straight from the card</a:t>
+            </a:r>
+          </a:p>
+        </p:txBody>
+      </p:sp>
+      <p:sp>
+        <p:nvSpPr>
+          <p:cNvPr id="3" name="TextBox 2"/>
+          <p:cNvSpPr txBox="1"/>
+          <p:nvPr/>
+        </p:nvSpPr>
+        <p:spPr>
+          <a:xfrm>
+            <a:off x="502920" y="1417320"/>
+            <a:ext cx="3977639" cy="5120640"/>
+          </a:xfrm>
+          <a:prstGeom prst="rect">
+            <a:avLst/>
+          </a:prstGeom>
+          <a:noFill/>
+        </p:spPr>
+        <p:txBody>
+          <a:bodyPr wrap="square">
+            <a:spAutoFit/>
+          </a:bodyPr>
+          <a:lstStyle/>
+          <a:p>
+            <a:pPr algn="l">
+              <a:spcAft>
+                <a:spcPts val="400"/>
+              </a:spcAft>
+            </a:pPr>
+            <a:r>
+              <a:rPr sz="1400" b="1">
+                <a:solidFill>
+                  <a:srgbClr val="1F2937"/>
+                </a:solidFill>
+                <a:latin typeface="Segoe UI"/>
+              </a:rPr>
+              <a:t>The deliverable</a:t>
+            </a:r>
+          </a:p>
+          <a:p>
+            <a:pPr algn="l">
+              <a:spcAft>
+                <a:spcPts val="700"/>
+              </a:spcAft>
+            </a:pPr>
+            <a:r>
+              <a:rPr sz="1350" b="0">
+                <a:solidFill>
+                  <a:srgbClr val="374151"/>
+                </a:solidFill>
+                <a:latin typeface="Segoe UI"/>
+              </a:rPr>
+              <a:t>•  Excel / PDF buttons sit on each intersection card — export once the QA gate is clean.</a:t>
+            </a:r>
+          </a:p>
+          <a:p>
+            <a:pPr algn="l">
+              <a:spcAft>
+                <a:spcPts val="700"/>
+              </a:spcAft>
+            </a:pPr>
+            <a:r>
+              <a:rPr sz="1350" b="0">
+                <a:solidFill>
+                  <a:srgbClr val="374151"/>
+                </a:solidFill>
+                <a:latin typeface="Segoe UI"/>
+              </a:rPr>
+              <a:t>•  The file downloads as TMC_&lt;intersection&gt;_&lt;date&gt;.xlsx.</a:t>
+            </a:r>
+          </a:p>
+          <a:p>
+            <a:pPr algn="l">
+              <a:spcAft>
+                <a:spcPts val="700"/>
+              </a:spcAft>
+            </a:pPr>
+            <a:r>
+              <a:rPr sz="1350" b="0">
+                <a:solidFill>
+                  <a:srgbClr val="374151"/>
+                </a:solidFill>
+                <a:latin typeface="Segoe UI"/>
+              </a:rPr>
+              <a:t>•  Every export reflects the current reviewed state — re-export freely after more review.</a:t>
+            </a:r>
+          </a:p>
+        </p:txBody>
+      </p:sp>
+      <p:pic>
+        <p:nvPicPr>
+          <p:cNvPr id="4" name="Picture 3" descr="gif_06_export.gif"/>
+          <p:cNvPicPr>
+            <a:picLocks noChangeAspect="1"/>
+          </p:cNvPicPr>
+          <p:nvPr/>
+        </p:nvPicPr>
+        <p:blipFill>
+          <a:blip r:embed="rId2"/>
+          <a:stretch>
+            <a:fillRect/>
+          </a:stretch>
+        </p:blipFill>
+        <p:spPr>
+          <a:xfrm>
+            <a:off x="4617720" y="1481328"/>
+            <a:ext cx="7406640" cy="4167918"/>
+          </a:xfrm>
+          <a:prstGeom prst="rect">
+            <a:avLst/>
+          </a:prstGeom>
+          <a:ln w="12700">
+            <a:solidFill>
+              <a:srgbClr val="D1D5DB"/>
+            </a:solidFill>
+          </a:ln>
+        </p:spPr>
+      </p:pic>
+      <p:sp>
+        <p:nvSpPr>
+          <p:cNvPr id="5" name="TextBox 4"/>
+          <p:cNvSpPr txBox="1"/>
+          <p:nvPr/>
+        </p:nvSpPr>
+        <p:spPr>
+          <a:xfrm>
+            <a:off x="4617720" y="5806440"/>
+            <a:ext cx="7406640" cy="365760"/>
+          </a:xfrm>
+          <a:prstGeom prst="rect">
+            <a:avLst/>
+          </a:prstGeom>
+          <a:noFill/>
+        </p:spPr>
+        <p:txBody>
+          <a:bodyPr wrap="square">
+            <a:spAutoFit/>
+          </a:bodyPr>
+          <a:lstStyle/>
+          <a:p>
+            <a:pPr algn="l">
+              <a:spcAft>
+                <a:spcPts val="0"/>
+              </a:spcAft>
+            </a:pPr>
+            <a:r>
+              <a:rPr sz="1050" b="0">
+                <a:solidFill>
+                  <a:srgbClr val="6B7280"/>
+                </a:solidFill>
+                <a:latin typeface="Segoe UI"/>
+              </a:rPr>
+              <a:t>▶ One click; the workbook lands in Downloads.</a:t>
+            </a:r>
+          </a:p>
+        </p:txBody>
+      </p:sp>
+    </p:spTree>
+  </p:cSld>
+  <p:clrMapOvr>
+    <a:masterClrMapping/>
+  </p:clrMapOvr>
+</p:sld>
+</file>
+
+<file path=ppt/slides/slide23.xml><?xml version="1.0" encoding="utf-8"?>
+<p:sld xmlns:a="http://schemas.openxmlformats.org/drawingml/2006/main" xmlns:p="http://schemas.openxmlformats.org/presentationml/2006/main" xmlns:r="http://schemas.openxmlformats.org/officeDocument/2006/relationships">
+  <p:cSld>
+    <p:spTree>
+      <p:nvGrpSpPr>
+        <p:cNvPr id="1" name=""/>
+        <p:cNvGrpSpPr/>
+        <p:nvPr/>
+      </p:nvGrpSpPr>
+      <p:grpSpPr/>
+      <p:sp>
+        <p:nvSpPr>
+          <p:cNvPr id="2" name="TextBox 1"/>
+          <p:cNvSpPr txBox="1"/>
+          <p:nvPr/>
+        </p:nvSpPr>
+        <p:spPr>
+          <a:xfrm>
+            <a:off x="502920" y="256032"/>
+            <a:ext cx="11247120" cy="1005840"/>
+          </a:xfrm>
+          <a:prstGeom prst="rect">
+            <a:avLst/>
+          </a:prstGeom>
+          <a:noFill/>
+        </p:spPr>
+        <p:txBody>
+          <a:bodyPr wrap="square">
+            <a:spAutoFit/>
+          </a:bodyPr>
+          <a:lstStyle/>
+          <a:p>
+            <a:pPr algn="l">
+              <a:spcAft>
+                <a:spcPts val="200"/>
+              </a:spcAft>
+            </a:pPr>
+            <a:r>
+              <a:rPr sz="1200" b="1">
+                <a:solidFill>
+                  <a:srgbClr val="2563EB"/>
+                </a:solidFill>
+                <a:latin typeface="Segoe UI"/>
+              </a:rPr>
+              <a:t>STEP 9A · THE WORKBOOK</a:t>
+            </a:r>
+          </a:p>
+          <a:p>
+            <a:pPr algn="l">
+              <a:spcAft>
+                <a:spcPts val="0"/>
+              </a:spcAft>
+            </a:pPr>
+            <a:r>
+              <a:rPr sz="2600" b="1">
+                <a:solidFill>
+                  <a:srgbClr val="1F2937"/>
+                </a:solidFill>
+                <a:latin typeface="Segoe UI"/>
+              </a:rPr>
+              <a:t>What's inside the export</a:t>
+            </a:r>
+          </a:p>
+        </p:txBody>
+      </p:sp>
+      <p:sp>
+        <p:nvSpPr>
+          <p:cNvPr id="3" name="TextBox 2"/>
+          <p:cNvSpPr txBox="1"/>
+          <p:nvPr/>
+        </p:nvSpPr>
+        <p:spPr>
+          <a:xfrm>
+            <a:off x="502920" y="1417320"/>
+            <a:ext cx="3977639" cy="5120640"/>
+          </a:xfrm>
+          <a:prstGeom prst="rect">
+            <a:avLst/>
+          </a:prstGeom>
+          <a:noFill/>
+        </p:spPr>
+        <p:txBody>
+          <a:bodyPr wrap="square">
+            <a:spAutoFit/>
+          </a:bodyPr>
+          <a:lstStyle/>
+          <a:p>
+            <a:pPr algn="l">
+              <a:spcAft>
+                <a:spcPts val="400"/>
+              </a:spcAft>
+            </a:pPr>
+            <a:r>
+              <a:rPr sz="1400" b="1">
+                <a:solidFill>
+                  <a:srgbClr val="1F2937"/>
+                </a:solidFill>
+                <a:latin typeface="Segoe UI"/>
+              </a:rPr>
+              <a:t>Five sheets</a:t>
+            </a:r>
+          </a:p>
+          <a:p>
+            <a:pPr algn="l">
+              <a:spcAft>
+                <a:spcPts val="700"/>
+              </a:spcAft>
+            </a:pPr>
+            <a:r>
+              <a:rPr sz="1350" b="0">
+                <a:solidFill>
+                  <a:srgbClr val="374151"/>
+                </a:solidFill>
+                <a:latin typeface="Segoe UI"/>
+              </a:rPr>
+              <a:t>•  Contents — what each sheet holds.</a:t>
+            </a:r>
+          </a:p>
+          <a:p>
+            <a:pPr algn="l">
+              <a:spcAft>
+                <a:spcPts val="700"/>
+              </a:spcAft>
+            </a:pPr>
+            <a:r>
+              <a:rPr sz="1350" b="0">
+                <a:solidFill>
+                  <a:srgbClr val="374151"/>
+                </a:solidFill>
+                <a:latin typeface="Segoe UI"/>
+              </a:rPr>
+              <a:t>•  Summary — a TMC overview for the study date.</a:t>
+            </a:r>
+          </a:p>
+          <a:p>
+            <a:pPr algn="l">
+              <a:spcAft>
+                <a:spcPts val="700"/>
+              </a:spcAft>
+            </a:pPr>
+            <a:r>
+              <a:rPr sz="1350" b="0">
+                <a:solidFill>
+                  <a:srgbClr val="374151"/>
+                </a:solidFill>
+                <a:latin typeface="Segoe UI"/>
+              </a:rPr>
+              <a:t>•  TMV Table — per-approach L / T / R / U totals with Total In and Total Out (shown right: the real NorthwestDr export).</a:t>
+            </a:r>
+          </a:p>
+          <a:p>
+            <a:pPr algn="l">
+              <a:spcAft>
+                <a:spcPts val="700"/>
+              </a:spcAft>
+            </a:pPr>
+            <a:r>
+              <a:rPr sz="1350" b="0">
+                <a:solidFill>
+                  <a:srgbClr val="374151"/>
+                </a:solidFill>
+                <a:latin typeface="Segoe UI"/>
+              </a:rPr>
+              <a:t>•  TMV Data — every 15-min bin × approach × movement × vehicle class (Lights / Mediums / Articulated), 374 rows here.</a:t>
+            </a:r>
+          </a:p>
+          <a:p>
+            <a:pPr algn="l">
+              <a:spcAft>
+                <a:spcPts val="700"/>
+              </a:spcAft>
+            </a:pPr>
+            <a:r>
+              <a:rPr sz="1350" b="0">
+                <a:solidFill>
+                  <a:srgbClr val="374151"/>
+                </a:solidFill>
+                <a:latin typeface="Segoe UI"/>
+              </a:rPr>
+              <a:t>•  Raw Events — the event-level base data.</a:t>
+            </a:r>
+          </a:p>
+          <a:p>
+            <a:pPr algn="l">
+              <a:spcAft>
+                <a:spcPts val="600"/>
+              </a:spcAft>
+            </a:pPr>
+            <a:r>
+              <a:rPr sz="1250" b="1">
+                <a:solidFill>
+                  <a:srgbClr val="0E7A4E"/>
+                </a:solidFill>
+                <a:latin typeface="Segoe UI"/>
+              </a:rPr>
+              <a:t>Every figure is a hard-coded integer — no formulas — safe for any client tool.</a:t>
+            </a:r>
+          </a:p>
+        </p:txBody>
+      </p:sp>
+      <p:pic>
+        <p:nvPicPr>
+          <p:cNvPr id="4" name="Picture 3" descr="g6_02_workbook.png"/>
+          <p:cNvPicPr>
+            <a:picLocks noChangeAspect="1"/>
+          </p:cNvPicPr>
+          <p:nvPr/>
+        </p:nvPicPr>
+        <p:blipFill>
+          <a:blip r:embed="rId2"/>
+          <a:stretch>
+            <a:fillRect/>
+          </a:stretch>
+        </p:blipFill>
+        <p:spPr>
+          <a:xfrm>
+            <a:off x="4617720" y="1481328"/>
+            <a:ext cx="7406640" cy="4166235"/>
+          </a:xfrm>
+          <a:prstGeom prst="rect">
+            <a:avLst/>
+          </a:prstGeom>
+          <a:ln w="12700">
+            <a:solidFill>
+              <a:srgbClr val="D1D5DB"/>
+            </a:solidFill>
+          </a:ln>
+        </p:spPr>
+      </p:pic>
+      <p:sp>
+        <p:nvSpPr>
+          <p:cNvPr id="5" name="TextBox 4"/>
+          <p:cNvSpPr txBox="1"/>
+          <p:nvPr/>
+        </p:nvSpPr>
+        <p:spPr>
+          <a:xfrm>
+            <a:off x="4617720" y="5806440"/>
+            <a:ext cx="7406640" cy="365760"/>
+          </a:xfrm>
+          <a:prstGeom prst="rect">
+            <a:avLst/>
+          </a:prstGeom>
+          <a:noFill/>
+        </p:spPr>
+        <p:txBody>
+          <a:bodyPr wrap="square">
+            <a:spAutoFit/>
+          </a:bodyPr>
+          <a:lstStyle/>
+          <a:p>
+            <a:pPr algn="l">
+              <a:spcAft>
+                <a:spcPts val="0"/>
+              </a:spcAft>
+            </a:pPr>
+            <a:r>
+              <a:rPr sz="1050" b="0">
+                <a:solidFill>
+                  <a:srgbClr val="6B7280"/>
+                </a:solidFill>
+                <a:latin typeface="Segoe UI"/>
+              </a:rPr>
+              <a:t>Rendered from the actual exported workbook.</a:t>
+            </a:r>
+          </a:p>
+        </p:txBody>
+      </p:sp>
+    </p:spTree>
+  </p:cSld>
+  <p:clrMapOvr>
+    <a:masterClrMapping/>
+  </p:clrMapOvr>
+</p:sld>
+</file>
+
+<file path=ppt/slides/slide24.xml><?xml version="1.0" encoding="utf-8"?>
+<p:sld xmlns:a="http://schemas.openxmlformats.org/drawingml/2006/main" xmlns:p="http://schemas.openxmlformats.org/presentationml/2006/main" xmlns:r="http://schemas.openxmlformats.org/officeDocument/2006/relationships">
+  <p:cSld>
+    <p:spTree>
+      <p:nvGrpSpPr>
+        <p:cNvPr id="1" name=""/>
+        <p:cNvGrpSpPr/>
+        <p:nvPr/>
+      </p:nvGrpSpPr>
+      <p:grpSpPr/>
+      <p:sp>
+        <p:nvSpPr>
+          <p:cNvPr id="2" name="TextBox 1"/>
+          <p:cNvSpPr txBox="1"/>
+          <p:nvPr/>
+        </p:nvSpPr>
+        <p:spPr>
+          <a:xfrm>
+            <a:off x="502920" y="256032"/>
+            <a:ext cx="11247120" cy="1005840"/>
+          </a:xfrm>
+          <a:prstGeom prst="rect">
+            <a:avLst/>
+          </a:prstGeom>
+          <a:noFill/>
+        </p:spPr>
+        <p:txBody>
+          <a:bodyPr wrap="square">
+            <a:spAutoFit/>
+          </a:bodyPr>
+          <a:lstStyle/>
+          <a:p>
+            <a:pPr algn="l">
+              <a:spcAft>
+                <a:spcPts val="200"/>
+              </a:spcAft>
+            </a:pPr>
+            <a:r>
+              <a:rPr sz="1200" b="1">
+                <a:solidFill>
+                  <a:srgbClr val="2563EB"/>
+                </a:solidFill>
+                <a:latin typeface="Segoe UI"/>
+              </a:rPr>
+              <a:t>REFERENCE</a:t>
+            </a:r>
+          </a:p>
+          <a:p>
+            <a:pPr algn="l">
+              <a:spcAft>
+                <a:spcPts val="0"/>
+              </a:spcAft>
+            </a:pPr>
+            <a:r>
+              <a:rPr sz="2600" b="1">
+                <a:solidFill>
+                  <a:srgbClr val="1F2937"/>
+                </a:solidFill>
+                <a:latin typeface="Segoe UI"/>
+              </a:rPr>
+              <a:t>Tips, traps, and the keyboard</a:t>
+            </a:r>
+          </a:p>
+        </p:txBody>
+      </p:sp>
+      <p:sp>
+        <p:nvSpPr>
+          <p:cNvPr id="3" name="TextBox 2"/>
+          <p:cNvSpPr txBox="1"/>
+          <p:nvPr/>
+        </p:nvSpPr>
+        <p:spPr>
+          <a:xfrm>
+            <a:off x="502920" y="1463040"/>
+            <a:ext cx="5486400" cy="5120640"/>
+          </a:xfrm>
+          <a:prstGeom prst="rect">
+            <a:avLst/>
+          </a:prstGeom>
+          <a:noFill/>
+        </p:spPr>
+        <p:txBody>
+          <a:bodyPr wrap="square">
+            <a:spAutoFit/>
+          </a:bodyPr>
+          <a:lstStyle/>
+          <a:p>
+            <a:pPr algn="l">
+              <a:spcAft>
+                <a:spcPts val="400"/>
+              </a:spcAft>
+            </a:pPr>
+            <a:r>
+              <a:rPr sz="1400" b="1">
+                <a:solidFill>
+                  <a:srgbClr val="2563EB"/>
+                </a:solidFill>
+                <a:latin typeface="Segoe UI"/>
+              </a:rPr>
+              <a:t>Launching</a:t>
+            </a:r>
+          </a:p>
+          <a:p>
+            <a:pPr algn="l">
+              <a:spcAft>
+                <a:spcPts val="600"/>
+              </a:spcAft>
+            </a:pPr>
+            <a:r>
+              <a:rPr sz="1250" b="0">
+                <a:solidFill>
+                  <a:srgbClr val="374151"/>
+                </a:solidFill>
+                <a:latin typeface="Segoe UI"/>
+              </a:rPr>
+              <a:t>•  http://127.0.0.1:5000 — that port only. Desktop window: python run.pyw.</a:t>
+            </a:r>
+          </a:p>
+          <a:p>
+            <a:pPr algn="l">
+              <a:spcAft>
+                <a:spcPts val="600"/>
+              </a:spcAft>
+            </a:pPr>
+            <a:r>
+              <a:rPr sz="1250" b="0">
+                <a:solidFill>
+                  <a:srgbClr val="374151"/>
+                </a:solidFill>
+                <a:latin typeface="Segoe UI"/>
+              </a:rPr>
+              <a:t>•  Everything runs locally; footage never leaves the machine.</a:t>
+            </a:r>
+          </a:p>
+          <a:p>
+            <a:pPr algn="l">
+              <a:spcAft>
+                <a:spcPts val="400"/>
+              </a:spcAft>
+            </a:pPr>
+            <a:r>
+              <a:rPr sz="1400" b="1">
+                <a:solidFill>
+                  <a:srgbClr val="2563EB"/>
+                </a:solidFill>
+                <a:latin typeface="Segoe UI"/>
+              </a:rPr>
+              <a:t>Calibration</a:t>
+            </a:r>
+          </a:p>
+          <a:p>
+            <a:pPr algn="l">
+              <a:spcAft>
+                <a:spcPts val="600"/>
+              </a:spcAft>
+            </a:pPr>
+            <a:r>
+              <a:rPr sz="1250" b="0">
+                <a:solidFill>
+                  <a:srgbClr val="374151"/>
+                </a:solidFill>
+                <a:latin typeface="Segoe UI"/>
+              </a:rPr>
+              <a:t>•  T-junction? Set legs to 3 on the card first.</a:t>
+            </a:r>
+          </a:p>
+          <a:p>
+            <a:pPr algn="l">
+              <a:spcAft>
+                <a:spcPts val="600"/>
+              </a:spcAft>
+            </a:pPr>
+            <a:r>
+              <a:rPr sz="1250" b="0">
+                <a:solidFill>
+                  <a:srgbClr val="374151"/>
+                </a:solidFill>
+                <a:latin typeface="Segoe UI"/>
+              </a:rPr>
+              <a:t>•  Draw every movement incl. throughs; channels guide, trajectories decide.</a:t>
+            </a:r>
+          </a:p>
+          <a:p>
+            <a:pPr algn="l">
+              <a:spcAft>
+                <a:spcPts val="600"/>
+              </a:spcAft>
+            </a:pPr>
+            <a:r>
+              <a:rPr sz="1250" b="0">
+                <a:solidFill>
+                  <a:srgbClr val="374151"/>
+                </a:solidFill>
+                <a:latin typeface="Segoe UI"/>
+              </a:rPr>
+              <a:t>•  Auto-calibration improves with busier video.</a:t>
+            </a:r>
+          </a:p>
+          <a:p>
+            <a:pPr algn="l">
+              <a:spcAft>
+                <a:spcPts val="600"/>
+              </a:spcAft>
+            </a:pPr>
+            <a:r>
+              <a:rPr sz="1250" b="0">
+                <a:solidFill>
+                  <a:srgbClr val="374151"/>
+                </a:solidFill>
+                <a:latin typeface="Segoe UI"/>
+              </a:rPr>
+              <a:t>•  Nothing persists until Save — deliberate exits discard drafts.</a:t>
+            </a:r>
+          </a:p>
+          <a:p>
+            <a:pPr algn="l">
+              <a:spcAft>
+                <a:spcPts val="400"/>
+              </a:spcAft>
+            </a:pPr>
+            <a:r>
+              <a:rPr sz="1400" b="1">
+                <a:solidFill>
+                  <a:srgbClr val="2563EB"/>
+                </a:solidFill>
+                <a:latin typeface="Segoe UI"/>
+              </a:rPr>
+              <a:t>Processing</a:t>
+            </a:r>
+          </a:p>
+          <a:p>
+            <a:pPr algn="l">
+              <a:spcAft>
+                <a:spcPts val="600"/>
+              </a:spcAft>
+            </a:pPr>
+            <a:r>
+              <a:rPr sz="1250" b="0">
+                <a:solidFill>
+                  <a:srgbClr val="374151"/>
+                </a:solidFill>
+                <a:latin typeface="Segoe UI"/>
+              </a:rPr>
+              <a:t>•  Full-day + Balanced = overnight; start it at end of day.</a:t>
+            </a:r>
+          </a:p>
+          <a:p>
+            <a:pPr algn="l">
+              <a:spcAft>
+                <a:spcPts val="600"/>
+              </a:spcAft>
+            </a:pPr>
+            <a:r>
+              <a:rPr sz="1250" b="0">
+                <a:solidFill>
+                  <a:srgbClr val="374151"/>
+                </a:solidFill>
+                <a:latin typeface="Segoe UI"/>
+              </a:rPr>
+              <a:t>•  Don't edit app files or restart the server mid-run.</a:t>
+            </a:r>
+          </a:p>
+          <a:p>
+            <a:pPr algn="l">
+              <a:spcAft>
+                <a:spcPts val="600"/>
+              </a:spcAft>
+            </a:pPr>
+            <a:r>
+              <a:rPr sz="1250" b="0">
+                <a:solidFill>
+                  <a:srgbClr val="374151"/>
+                </a:solidFill>
+                <a:latin typeface="Segoe UI"/>
+              </a:rPr>
+              <a:t>•  An Error status is the LAST run's result — a fresh run replaces it.</a:t>
+            </a:r>
+          </a:p>
+        </p:txBody>
+      </p:sp>
+      <p:sp>
+        <p:nvSpPr>
+          <p:cNvPr id="4" name="TextBox 3"/>
+          <p:cNvSpPr txBox="1"/>
+          <p:nvPr/>
+        </p:nvSpPr>
+        <p:spPr>
+          <a:xfrm>
+            <a:off x="6309360" y="1463040"/>
+            <a:ext cx="5486400" cy="5120640"/>
+          </a:xfrm>
+          <a:prstGeom prst="rect">
+            <a:avLst/>
+          </a:prstGeom>
+          <a:noFill/>
+        </p:spPr>
+        <p:txBody>
+          <a:bodyPr wrap="square">
+            <a:spAutoFit/>
+          </a:bodyPr>
+          <a:lstStyle/>
+          <a:p>
+            <a:pPr algn="l">
+              <a:spcAft>
+                <a:spcPts val="400"/>
+              </a:spcAft>
+            </a:pPr>
+            <a:r>
+              <a:rPr sz="1400" b="1">
+                <a:solidFill>
+                  <a:srgbClr val="2563EB"/>
+                </a:solidFill>
+                <a:latin typeface="Segoe UI"/>
+              </a:rPr>
+              <a:t>Review keyboard</a:t>
+            </a:r>
+          </a:p>
+          <a:p>
+            <a:pPr algn="l">
+              <a:spcAft>
+                <a:spcPts val="600"/>
+              </a:spcAft>
+            </a:pPr>
+            <a:r>
+              <a:rPr sz="1250" b="0">
+                <a:solidFill>
+                  <a:srgbClr val="374151"/>
+                </a:solidFill>
+                <a:latin typeface="Segoe UI"/>
+              </a:rPr>
+              <a:t>•  Enter — accept (“done, looks counted”)</a:t>
+            </a:r>
+          </a:p>
+          <a:p>
+            <a:pPr algn="l">
+              <a:spcAft>
+                <a:spcPts val="600"/>
+              </a:spcAft>
+            </a:pPr>
+            <a:r>
+              <a:rPr sz="1250" b="0">
+                <a:solidFill>
+                  <a:srgbClr val="374151"/>
+                </a:solidFill>
+                <a:latin typeface="Segoe UI"/>
+              </a:rPr>
+              <a:t>•  A — add a missed vehicle    ·    D — dismiss (real low volume)</a:t>
+            </a:r>
+          </a:p>
+          <a:p>
+            <a:pPr algn="l">
+              <a:spcAft>
+                <a:spcPts val="600"/>
+              </a:spcAft>
+            </a:pPr>
+            <a:r>
+              <a:rPr sz="1250" b="0">
+                <a:solidFill>
+                  <a:srgbClr val="374151"/>
+                </a:solidFill>
+                <a:latin typeface="Segoe UI"/>
+              </a:rPr>
+              <a:t>•  Del — reject a duplicate/false event</a:t>
+            </a:r>
+          </a:p>
+          <a:p>
+            <a:pPr algn="l">
+              <a:spcAft>
+                <a:spcPts val="600"/>
+              </a:spcAft>
+            </a:pPr>
+            <a:r>
+              <a:rPr sz="1250" b="0">
+                <a:solidFill>
+                  <a:srgbClr val="374151"/>
+                </a:solidFill>
+                <a:latin typeface="Segoe UI"/>
+              </a:rPr>
+              <a:t>•  1–4 — set movement    ·    Shift+1–4 — batch movement</a:t>
+            </a:r>
+          </a:p>
+          <a:p>
+            <a:pPr algn="l">
+              <a:spcAft>
+                <a:spcPts val="600"/>
+              </a:spcAft>
+            </a:pPr>
+            <a:r>
+              <a:rPr sz="1250" b="0">
+                <a:solidFill>
+                  <a:srgbClr val="374151"/>
+                </a:solidFill>
+                <a:latin typeface="Segoe UI"/>
+              </a:rPr>
+              <a:t>•  → — skip    ·    . — next in group    ·    B — resolve group</a:t>
+            </a:r>
+          </a:p>
+          <a:p>
+            <a:pPr algn="l">
+              <a:spcAft>
+                <a:spcPts val="600"/>
+              </a:spcAft>
+            </a:pPr>
+            <a:r>
+              <a:rPr sz="1250" b="0">
+                <a:solidFill>
+                  <a:srgbClr val="374151"/>
+                </a:solidFill>
+                <a:latin typeface="Segoe UI"/>
+              </a:rPr>
+              <a:t>•  Z — undo anything</a:t>
+            </a:r>
+          </a:p>
+          <a:p>
+            <a:pPr algn="l">
+              <a:spcAft>
+                <a:spcPts val="400"/>
+              </a:spcAft>
+            </a:pPr>
+            <a:r>
+              <a:rPr sz="1400" b="1">
+                <a:solidFill>
+                  <a:srgbClr val="2563EB"/>
+                </a:solidFill>
+                <a:latin typeface="Segoe UI"/>
+              </a:rPr>
+              <a:t>QA &amp; export</a:t>
+            </a:r>
+          </a:p>
+          <a:p>
+            <a:pPr algn="l">
+              <a:spcAft>
+                <a:spcPts val="600"/>
+              </a:spcAft>
+            </a:pPr>
+            <a:r>
+              <a:rPr sz="1250" b="0">
+                <a:solidFill>
+                  <a:srgbClr val="374151"/>
+                </a:solidFill>
+                <a:latin typeface="Segoe UI"/>
+              </a:rPr>
+              <a:t>•  Corridor FAIL: investigate on the QA tab — flags won't clear it.</a:t>
+            </a:r>
+          </a:p>
+          <a:p>
+            <a:pPr algn="l">
+              <a:spcAft>
+                <a:spcPts val="600"/>
+              </a:spcAft>
+            </a:pPr>
+            <a:r>
+              <a:rPr sz="1250" b="0">
+                <a:solidFill>
+                  <a:srgbClr val="374151"/>
+                </a:solidFill>
+                <a:latin typeface="Segoe UI"/>
+              </a:rPr>
+              <a:t>•  Record a spot count on every study (~850 veh certifies ±10%).</a:t>
+            </a:r>
+          </a:p>
+          <a:p>
+            <a:pPr algn="l">
+              <a:spcAft>
+                <a:spcPts val="600"/>
+              </a:spcAft>
+            </a:pPr>
+            <a:r>
+              <a:rPr sz="1250" b="0">
+                <a:solidFill>
+                  <a:srgbClr val="374151"/>
+                </a:solidFill>
+                <a:latin typeface="Segoe UI"/>
+              </a:rPr>
+              <a:t>•  Export per card; re-export freely after review.</a:t>
             </a:r>
           </a:p>
         </p:txBody>
@@ -5561,7 +8253,7 @@
                 </a:solidFill>
                 <a:latin typeface="Segoe UI"/>
               </a:rPr>
-              <a:t>•  Every project is a site visit: create one per study, name it after the corridor or client.</a:t>
+              <a:t>•  Every project is a site visit: one per study, named after the corridor or client.</a:t>
             </a:r>
           </a:p>
           <a:p>
@@ -5577,7 +8269,7 @@
                 </a:solidFill>
                 <a:latin typeface="Segoe UI"/>
               </a:rPr>
-              <a:t>•  Status chips tell you where each project stands — created, idle, complete, interrupted, needs calibration, needs video.</a:t>
+              <a:t>•  Status chips: created, idle, complete, interrupted, needs calibration, needs video.</a:t>
             </a:r>
           </a:p>
           <a:p>
@@ -5593,7 +8285,7 @@
                 </a:solidFill>
                 <a:latin typeface="Segoe UI"/>
               </a:rPr>
-              <a:t>•  “Start All Calibrated” batch-runs every project that is ready to go.</a:t>
+              <a:t>•  “Start All Calibrated” batch-runs every ready project.</a:t>
             </a:r>
           </a:p>
           <a:p>
@@ -5651,7 +8343,7 @@
         </p:nvSpPr>
         <p:spPr>
           <a:xfrm>
-            <a:off x="4617720" y="5715000"/>
+            <a:off x="4617720" y="5806440"/>
             <a:ext cx="7406640" cy="365760"/>
           </a:xfrm>
           <a:prstGeom prst="rect">
@@ -5734,7 +8426,7 @@
                 </a:solidFill>
                 <a:latin typeface="Segoe UI"/>
               </a:rPr>
-              <a:t>STEP 2 · VIDEOS</a:t>
+              <a:t>STEP 1 · ▶ IN MOTION</a:t>
             </a:r>
           </a:p>
           <a:p>
@@ -5750,7 +8442,7 @@
                 </a:solidFill>
                 <a:latin typeface="Segoe UI"/>
               </a:rPr>
-              <a:t>Upload the day's footage</a:t>
+              <a:t>From the projects list into a card</a:t>
             </a:r>
           </a:p>
         </p:txBody>
@@ -5789,7 +8481,7 @@
                 </a:solidFill>
                 <a:latin typeface="Segoe UI"/>
               </a:rPr>
-              <a:t>One drag-and-drop</a:t>
+              <a:t>Four clicks to the work</a:t>
             </a:r>
           </a:p>
           <a:p>
@@ -5805,7 +8497,7 @@
                 </a:solidFill>
                 <a:latin typeface="Segoe UI"/>
               </a:rPr>
-              <a:t>•  Drop all cameras' files at once; camera number, date, start time and intersection name auto-fill from the filename.</a:t>
+              <a:t>•  Open the project → it lands on Videos.</a:t>
             </a:r>
           </a:p>
           <a:p>
@@ -5821,7 +8513,7 @@
                 </a:solidFill>
                 <a:latin typeface="Segoe UI"/>
               </a:rPr>
-              <a:t>•  The Confidence column shows how sure the parser is — verify anything under 100% and fix the fields inline.</a:t>
+              <a:t>•  Switch to the Intersections tab.</a:t>
             </a:r>
           </a:p>
           <a:p>
@@ -5837,7 +8529,7 @@
                 </a:solidFill>
                 <a:latin typeface="Segoe UI"/>
               </a:rPr>
-              <a:t>•  The Intersection field is what groups videos into cards — same spelling = same card.</a:t>
+              <a:t>•  Open the card you're working — everything for that intersection × date lives inside.</a:t>
             </a:r>
           </a:p>
           <a:p>
@@ -5853,30 +8545,14 @@
                 </a:solidFill>
                 <a:latin typeface="Segoe UI"/>
               </a:rPr>
-              <a:t>•  Renamed a label after cards were built? Click “Re-sync labels”.</a:t>
-            </a:r>
-          </a:p>
-          <a:p>
-            <a:pPr algn="l">
-              <a:spcAft>
-                <a:spcPts val="600"/>
-              </a:spcAft>
-            </a:pPr>
-            <a:r>
-              <a:rPr sz="1250" b="1">
-                <a:solidFill>
-                  <a:srgbClr val="B45309"/>
-                </a:solidFill>
-                <a:latin typeface="Segoe UI"/>
-              </a:rPr>
-              <a:t>⚠  Set the true wall-clock start time — every trim and count bin hangs off it.</a:t>
+              <a:t>•  The animation plays in slideshow mode; the orange ring marks each click.</a:t>
             </a:r>
           </a:p>
         </p:txBody>
       </p:sp>
       <p:pic>
         <p:nvPicPr>
-          <p:cNvPr id="4" name="Picture 3" descr="guide_02_videos_tab.png"/>
+          <p:cNvPr id="4" name="Picture 3" descr="gif_01_open_card.gif"/>
           <p:cNvPicPr>
             <a:picLocks noChangeAspect="1"/>
           </p:cNvPicPr>
@@ -5891,7 +8567,7 @@
         <p:spPr>
           <a:xfrm>
             <a:off x="4617720" y="1481328"/>
-            <a:ext cx="7406640" cy="4166235"/>
+            <a:ext cx="7406640" cy="4167918"/>
           </a:xfrm>
           <a:prstGeom prst="rect">
             <a:avLst/>
@@ -5911,7 +8587,7 @@
         </p:nvSpPr>
         <p:spPr>
           <a:xfrm>
-            <a:off x="4617720" y="5715000"/>
+            <a:off x="4617720" y="5806440"/>
             <a:ext cx="7406640" cy="365760"/>
           </a:xfrm>
           <a:prstGeom prst="rect">
@@ -5937,7 +8613,7 @@
                 </a:solidFill>
                 <a:latin typeface="Segoe UI"/>
               </a:rPr>
-              <a:t>Five 24-hour cameras parsed straight from their filenames.</a:t>
+              <a:t>▶ Projects → project → Intersections tab → card.</a:t>
             </a:r>
           </a:p>
         </p:txBody>
@@ -5994,7 +8670,7 @@
                 </a:solidFill>
                 <a:latin typeface="Segoe UI"/>
               </a:rPr>
-              <a:t>STEP 3 · INTERSECTIONS</a:t>
+              <a:t>STEP 2 · VIDEOS</a:t>
             </a:r>
           </a:p>
           <a:p>
@@ -6010,7 +8686,7 @@
                 </a:solidFill>
                 <a:latin typeface="Segoe UI"/>
               </a:rPr>
-              <a:t>One card per intersection × date</a:t>
+              <a:t>Upload the day's footage</a:t>
             </a:r>
           </a:p>
         </p:txBody>
@@ -6049,7 +8725,7 @@
                 </a:solidFill>
                 <a:latin typeface="Segoe UI"/>
               </a:rPr>
-              <a:t>The card is the unit of work</a:t>
+              <a:t>One drag-and-drop</a:t>
             </a:r>
           </a:p>
           <a:p>
@@ -6065,7 +8741,7 @@
                 </a:solidFill>
                 <a:latin typeface="Segoe UI"/>
               </a:rPr>
-              <a:t>•  Each card bundles that intersection's cameras, calibration, trims, QA and exports for one study date.</a:t>
+              <a:t>•  Drop all cameras' files at once; camera, date, start time and intersection auto-fill from the filename.</a:t>
             </a:r>
           </a:p>
           <a:p>
@@ -6081,7 +8757,7 @@
                 </a:solidFill>
                 <a:latin typeface="Segoe UI"/>
               </a:rPr>
-              <a:t>•  Open drills into the card; Excel and PDF export straight from this list once processing is done.</a:t>
+              <a:t>•  Confidence under 100%? Verify and fix the fields inline.</a:t>
             </a:r>
           </a:p>
           <a:p>
@@ -6097,7 +8773,7 @@
                 </a:solidFill>
                 <a:latin typeface="Segoe UI"/>
               </a:rPr>
-              <a:t>•  Legs count on the card is a quick sanity check — a T-junction should say 3.</a:t>
+              <a:t>•  The Intersection field groups videos into cards — same spelling, same card.</a:t>
             </a:r>
           </a:p>
           <a:p>
@@ -6113,14 +8789,30 @@
                 </a:solidFill>
                 <a:latin typeface="Segoe UI"/>
               </a:rPr>
-              <a:t>•  Multiple cameras on one intersection? They all live inside the same card and de-duplicate at count time.</a:t>
+              <a:t>•  Renamed a label later? “Re-sync labels”.</a:t>
+            </a:r>
+          </a:p>
+          <a:p>
+            <a:pPr algn="l">
+              <a:spcAft>
+                <a:spcPts val="600"/>
+              </a:spcAft>
+            </a:pPr>
+            <a:r>
+              <a:rPr sz="1250" b="1">
+                <a:solidFill>
+                  <a:srgbClr val="B45309"/>
+                </a:solidFill>
+                <a:latin typeface="Segoe UI"/>
+              </a:rPr>
+              <a:t>⚠  Set the true wall-clock start time — every trim and count bin hangs off it.</a:t>
             </a:r>
           </a:p>
         </p:txBody>
       </p:sp>
       <p:pic>
         <p:nvPicPr>
-          <p:cNvPr id="4" name="Picture 3" descr="guide_03_intersections_tab.png"/>
+          <p:cNvPr id="4" name="Picture 3" descr="guide_02_videos_tab.png"/>
           <p:cNvPicPr>
             <a:picLocks noChangeAspect="1"/>
           </p:cNvPicPr>
@@ -6155,7 +8847,7 @@
         </p:nvSpPr>
         <p:spPr>
           <a:xfrm>
-            <a:off x="4617720" y="5715000"/>
+            <a:off x="4617720" y="5806440"/>
             <a:ext cx="7406640" cy="365760"/>
           </a:xfrm>
           <a:prstGeom prst="rect">
@@ -6181,7 +8873,7 @@
                 </a:solidFill>
                 <a:latin typeface="Segoe UI"/>
               </a:rPr>
-              <a:t>The five Belt Line Rd cards for the 2026-05-12 study.</a:t>
+              <a:t>Five 24-hour cameras parsed straight from their filenames.</a:t>
             </a:r>
           </a:p>
         </p:txBody>
@@ -6238,7 +8930,7 @@
                 </a:solidFill>
                 <a:latin typeface="Segoe UI"/>
               </a:rPr>
-              <a:t>STEP 4 · CARD SETTINGS</a:t>
+              <a:t>STEP 3 · INTERSECTIONS</a:t>
             </a:r>
           </a:p>
           <a:p>
@@ -6254,7 +8946,7 @@
                 </a:solidFill>
                 <a:latin typeface="Segoe UI"/>
               </a:rPr>
-              <a:t>Check the basics before calibrating</a:t>
+              <a:t>One card per intersection × date</a:t>
             </a:r>
           </a:p>
         </p:txBody>
@@ -6293,7 +8985,7 @@
                 </a:solidFill>
                 <a:latin typeface="Segoe UI"/>
               </a:rPr>
-              <a:t>Thirty seconds of setup</a:t>
+              <a:t>The card is the unit of work</a:t>
             </a:r>
           </a:p>
           <a:p>
@@ -6309,7 +9001,7 @@
                 </a:solidFill>
                 <a:latin typeface="Segoe UI"/>
               </a:rPr>
-              <a:t>•  Confirm the intersection name and the number of legs — 4 is the default; T-junctions use 3.</a:t>
+              <a:t>•  Each card bundles that intersection's cameras, calibration, trims, QA and exports for one study date.</a:t>
             </a:r>
           </a:p>
           <a:p>
@@ -6325,7 +9017,7 @@
                 </a:solidFill>
                 <a:latin typeface="Segoe UI"/>
               </a:rPr>
-              <a:t>•  The summary shows how many cameras are configured and how many trims are defined.</a:t>
+              <a:t>•  Open drills in; Excel / PDF export straight from this list once processing is done.</a:t>
             </a:r>
           </a:p>
           <a:p>
@@ -6341,7 +9033,7 @@
                 </a:solidFill>
                 <a:latin typeface="Segoe UI"/>
               </a:rPr>
-              <a:t>•  “Two-pass readiness” lists every camera × trim window and whether each pass is ready, stale, or missing.</a:t>
+              <a:t>•  Legs count is a sanity check — a T-junction should say 3.</a:t>
             </a:r>
           </a:p>
           <a:p>
@@ -6357,14 +9049,14 @@
                 </a:solidFill>
                 <a:latin typeface="Segoe UI"/>
               </a:rPr>
-              <a:t>•  “Confirm &amp; process” launches everything that panel says will run — check it reads the way you expect first.</a:t>
+              <a:t>•  Multiple cameras on one intersection live in the same card and de-duplicate at count time.</a:t>
             </a:r>
           </a:p>
         </p:txBody>
       </p:sp>
       <p:pic>
         <p:nvPicPr>
-          <p:cNvPr id="4" name="Picture 3" descr="guide_04_card_settings.png"/>
+          <p:cNvPr id="4" name="Picture 3" descr="guide_03_intersections_tab.png"/>
           <p:cNvPicPr>
             <a:picLocks noChangeAspect="1"/>
           </p:cNvPicPr>
@@ -6399,7 +9091,7 @@
         </p:nvSpPr>
         <p:spPr>
           <a:xfrm>
-            <a:off x="4617720" y="5715000"/>
+            <a:off x="4617720" y="5806440"/>
             <a:ext cx="7406640" cy="365760"/>
           </a:xfrm>
           <a:prstGeom prst="rect">
@@ -6425,7 +9117,7 @@
                 </a:solidFill>
                 <a:latin typeface="Segoe UI"/>
               </a:rPr>
-              <a:t>Readiness per window: pass-1 ready, pass-2 will re-run.</a:t>
+              <a:t>The five Belt Line Rd cards for the 2026-05-12 study.</a:t>
             </a:r>
           </a:p>
         </p:txBody>
@@ -6482,7 +9174,7 @@
                 </a:solidFill>
                 <a:latin typeface="Segoe UI"/>
               </a:rPr>
-              <a:t>STEP 5 · CAMERAS</a:t>
+              <a:t>STEP 4 · CARD SETTINGS</a:t>
             </a:r>
           </a:p>
           <a:p>
@@ -6498,7 +9190,7 @@
                 </a:solidFill>
                 <a:latin typeface="Segoe UI"/>
               </a:rPr>
-              <a:t>Each camera gets its own calibration</a:t>
+              <a:t>Check the basics; learn the readiness panel</a:t>
             </a:r>
           </a:p>
         </p:txBody>
@@ -6537,7 +9229,7 @@
                 </a:solidFill>
                 <a:latin typeface="Segoe UI"/>
               </a:rPr>
-              <a:t>Per-camera geometry</a:t>
+              <a:t>Thirty seconds of setup</a:t>
             </a:r>
           </a:p>
           <a:p>
@@ -6553,7 +9245,7 @@
                 </a:solidFill>
                 <a:latin typeface="Segoe UI"/>
               </a:rPr>
-              <a:t>•  Every camera sees the intersection from its own angle, so legs and channels are drawn per camera.</a:t>
+              <a:t>•  Confirm the name and the number of legs (4 default; T-junctions 3).</a:t>
             </a:r>
           </a:p>
           <a:p>
@@ -6569,7 +9261,7 @@
                 </a:solidFill>
                 <a:latin typeface="Segoe UI"/>
               </a:rPr>
-              <a:t>•  ✓ Configured means geometry exists; Recalibrate opens the editor to view or adjust it.</a:t>
+              <a:t>•  “Two-pass readiness” lists every camera × trim window: pass-1 is detection + tracking (the slow overnight part); pass-2 is classification + merge (fast, re-runnable).</a:t>
             </a:r>
           </a:p>
           <a:p>
@@ -6585,14 +9277,46 @@
                 </a:solidFill>
                 <a:latin typeface="Segoe UI"/>
               </a:rPr>
-              <a:t>•  The footage rating stars (below) say whether this video supports the count guarantee — 1080p-class footage earns the full per-movement guarantee.</a:t>
+              <a:t>•  “pass-2 stale — will re-run” just means classification will refresh on the next run — pass-1 work is preserved.</a:t>
+            </a:r>
+          </a:p>
+          <a:p>
+            <a:pPr algn="l">
+              <a:spcAft>
+                <a:spcPts val="700"/>
+              </a:spcAft>
+            </a:pPr>
+            <a:r>
+              <a:rPr sz="1350" b="0">
+                <a:solidFill>
+                  <a:srgbClr val="374151"/>
+                </a:solidFill>
+                <a:latin typeface="Segoe UI"/>
+              </a:rPr>
+              <a:t>•  “Confirm &amp; process” launches exactly what the panel lists — read it first.</a:t>
+            </a:r>
+          </a:p>
+          <a:p>
+            <a:pPr algn="l">
+              <a:spcAft>
+                <a:spcPts val="600"/>
+              </a:spcAft>
+            </a:pPr>
+            <a:r>
+              <a:rPr sz="1250" b="1">
+                <a:solidFill>
+                  <a:srgbClr val="0E7A4E"/>
+                </a:solidFill>
+                <a:latin typeface="Segoe UI"/>
+              </a:rPr>
+              <a:t>The ▶ card-tabs animation: Settings → Cameras → Clip trim → QA.</a:t>
             </a:r>
           </a:p>
         </p:txBody>
       </p:sp>
       <p:pic>
         <p:nvPicPr>
-          <p:cNvPr id="4" name="Picture 3" descr="guide_05_cameras_tab.png"/>
+          <p:cNvPr id="4" name="Picture 3" descr="gif_02_card_tabs.gif"/>
           <p:cNvPicPr>
             <a:picLocks noChangeAspect="1"/>
           </p:cNvPicPr>
@@ -6607,7 +9331,7 @@
         <p:spPr>
           <a:xfrm>
             <a:off x="4617720" y="1481328"/>
-            <a:ext cx="7406640" cy="4166235"/>
+            <a:ext cx="7406640" cy="4167918"/>
           </a:xfrm>
           <a:prstGeom prst="rect">
             <a:avLst/>
@@ -6627,7 +9351,7 @@
         </p:nvSpPr>
         <p:spPr>
           <a:xfrm>
-            <a:off x="4617720" y="5715000"/>
+            <a:off x="4617720" y="5806440"/>
             <a:ext cx="7406640" cy="365760"/>
           </a:xfrm>
           <a:prstGeom prst="rect">
@@ -6653,7 +9377,7 @@
                 </a:solidFill>
                 <a:latin typeface="Segoe UI"/>
               </a:rPr>
-              <a:t>One camera on this card, already calibrated.</a:t>
+              <a:t>▶ The four sub-tabs of an intersection card.</a:t>
             </a:r>
           </a:p>
         </p:txBody>
@@ -6710,7 +9434,7 @@
                 </a:solidFill>
                 <a:latin typeface="Segoe UI"/>
               </a:rPr>
-              <a:t>STEP 5A · CALIBRATION</a:t>
+              <a:t>STEP 5 · CAMERAS</a:t>
             </a:r>
           </a:p>
           <a:p>
@@ -6726,7 +9450,7 @@
                 </a:solidFill>
                 <a:latin typeface="Segoe UI"/>
               </a:rPr>
-              <a:t>Legs — let auto-calibration do the first pass</a:t>
+              <a:t>Each camera gets its own calibration</a:t>
             </a:r>
           </a:p>
         </p:txBody>
@@ -6765,7 +9489,7 @@
                 </a:solidFill>
                 <a:latin typeface="Segoe UI"/>
               </a:rPr>
-              <a:t>Start from the proposal</a:t>
+              <a:t>Per-camera geometry</a:t>
             </a:r>
           </a:p>
           <a:p>
@@ -6781,7 +9505,7 @@
                 </a:solidFill>
                 <a:latin typeface="Segoe UI"/>
               </a:rPr>
-              <a:t>•  Auto-calibration watches real trajectories and proposes legs and road paths — Preview it, then Apply or Reject.</a:t>
+              <a:t>•  Every camera sees the intersection from its own angle; legs and channels are drawn per camera.</a:t>
             </a:r>
           </a:p>
           <a:p>
@@ -6797,7 +9521,7 @@
                 </a:solidFill>
                 <a:latin typeface="Segoe UI"/>
               </a:rPr>
-              <a:t>•  Place all legs (4/4 here): each leg is an approach mouth with its compass direction (NB/SB/EB/WB).</a:t>
+              <a:t>•  ✓ Configured = geometry exists; Recalibrate opens the editor.</a:t>
             </a:r>
           </a:p>
           <a:p>
@@ -6813,46 +9537,14 @@
                 </a:solidFill>
                 <a:latin typeface="Segoe UI"/>
               </a:rPr>
-              <a:t>•  Scrub the video timeline to a clear, busy moment before judging the geometry.</a:t>
-            </a:r>
-          </a:p>
-          <a:p>
-            <a:pPr algn="l">
-              <a:spcAft>
-                <a:spcPts val="700"/>
-              </a:spcAft>
-            </a:pPr>
-            <a:r>
-              <a:rPr sz="1350" b="0">
-                <a:solidFill>
-                  <a:srgbClr val="374151"/>
-                </a:solidFill>
-                <a:latin typeface="Segoe UI"/>
-              </a:rPr>
-              <a:t>•  The layers panel toggles each approach's Legs / Paths / Channels overlays on and off while you work.</a:t>
-            </a:r>
-          </a:p>
-          <a:p>
-            <a:pPr algn="l">
-              <a:spcAft>
-                <a:spcPts val="600"/>
-              </a:spcAft>
-            </a:pPr>
-            <a:r>
-              <a:rPr sz="1250" b="1">
-                <a:solidFill>
-                  <a:srgbClr val="B45309"/>
-                </a:solidFill>
-                <a:latin typeface="Segoe UI"/>
-              </a:rPr>
-              <a:t>⚠  Get the cardinal labels right — every movement name (NB left, EB through…) derives from them.</a:t>
+              <a:t>•  Footage rating stars say whether this video supports the count guarantee — 1080p-class earns the full per-movement guarantee.</a:t>
             </a:r>
           </a:p>
         </p:txBody>
       </p:sp>
       <p:pic>
         <p:nvPicPr>
-          <p:cNvPr id="4" name="Picture 3" descr="guide_06_calibration_editor.png"/>
+          <p:cNvPr id="4" name="Picture 3" descr="guide_05_cameras_tab.png"/>
           <p:cNvPicPr>
             <a:picLocks noChangeAspect="1"/>
           </p:cNvPicPr>
@@ -6887,7 +9579,7 @@
         </p:nvSpPr>
         <p:spPr>
           <a:xfrm>
-            <a:off x="4617720" y="5715000"/>
+            <a:off x="4617720" y="5806440"/>
             <a:ext cx="7406640" cy="365760"/>
           </a:xfrm>
           <a:prstGeom prst="rect">
@@ -6913,7 +9605,7 @@
                 </a:solidFill>
                 <a:latin typeface="Segoe UI"/>
               </a:rPr>
-              <a:t>The calibration editor: wizard steps on the right, layer toggles on the left.</a:t>
+              <a:t>One camera on this card, already calibrated.</a:t>
             </a:r>
           </a:p>
         </p:txBody>
@@ -6970,7 +9662,7 @@
                 </a:solidFill>
                 <a:latin typeface="Segoe UI"/>
               </a:rPr>
-              <a:t>STEP 5B · CALIBRATION</a:t>
+              <a:t>STEP 5A · CALIBRATION</a:t>
             </a:r>
           </a:p>
           <a:p>
@@ -6986,7 +9678,7 @@
                 </a:solidFill>
                 <a:latin typeface="Segoe UI"/>
               </a:rPr>
-              <a:t>Channels — sketch how traffic moves</a:t>
+              <a:t>Legs — let auto-calibration make the first pass</a:t>
             </a:r>
           </a:p>
         </p:txBody>
@@ -7025,7 +9717,7 @@
                 </a:solidFill>
                 <a:latin typeface="Segoe UI"/>
               </a:rPr>
-              <a:t>Guidelines, not fences</a:t>
+              <a:t>Start from the proposal</a:t>
             </a:r>
           </a:p>
           <a:p>
@@ -7041,7 +9733,7 @@
                 </a:solidFill>
                 <a:latin typeface="Segoe UI"/>
               </a:rPr>
-              <a:t>•  A channel is a movement's corridor: click entry → bend → exit; the ends snap to the nearest leg.</a:t>
+              <a:t>•  Auto-calibration watches real trajectories and proposes legs and road paths — Preview, then Apply or Reject.</a:t>
             </a:r>
           </a:p>
           <a:p>
@@ -7057,7 +9749,7 @@
                 </a:solidFill>
                 <a:latin typeface="Segoe UI"/>
               </a:rPr>
-              <a:t>•  Draw THROUGHS too, not just turns — the classifier needs the straight movements as context.</a:t>
+              <a:t>•  Each leg is an approach mouth with its compass direction.</a:t>
             </a:r>
           </a:p>
           <a:p>
@@ -7073,30 +9765,30 @@
                 </a:solidFill>
                 <a:latin typeface="Segoe UI"/>
               </a:rPr>
-              <a:t>•  Channels are general layout guidance for the classifier — cars share mouths and drift across lanes; the trajectory over time decides the turn, not the lane markings.</a:t>
-            </a:r>
-          </a:p>
-          <a:p>
-            <a:pPr algn="l">
-              <a:spcAft>
-                <a:spcPts val="700"/>
-              </a:spcAft>
-            </a:pPr>
-            <a:r>
-              <a:rPr sz="1350" b="0">
-                <a:solidFill>
-                  <a:srgbClr val="374151"/>
-                </a:solidFill>
-                <a:latin typeface="Segoe UI"/>
-              </a:rPr>
-              <a:t>•  16 channels drawn here = all movements incl. U-turns at a 4-leg intersection.</a:t>
+              <a:t>•  Scrub to a busy moment before judging geometry.</a:t>
+            </a:r>
+          </a:p>
+          <a:p>
+            <a:pPr algn="l">
+              <a:spcAft>
+                <a:spcPts val="600"/>
+              </a:spcAft>
+            </a:pPr>
+            <a:r>
+              <a:rPr sz="1250" b="1">
+                <a:solidFill>
+                  <a:srgbClr val="B45309"/>
+                </a:solidFill>
+                <a:latin typeface="Segoe UI"/>
+              </a:rPr>
+              <a:t>⚠  Get the cardinal labels right — every movement name (NB left, EB through…) derives from them.</a:t>
             </a:r>
           </a:p>
         </p:txBody>
       </p:sp>
       <p:pic>
         <p:nvPicPr>
-          <p:cNvPr id="4" name="Picture 3" descr="guide_07_calibration_channels.png"/>
+          <p:cNvPr id="4" name="Picture 3" descr="guide_06_calibration_editor.png"/>
           <p:cNvPicPr>
             <a:picLocks noChangeAspect="1"/>
           </p:cNvPicPr>
@@ -7131,7 +9823,7 @@
         </p:nvSpPr>
         <p:spPr>
           <a:xfrm>
-            <a:off x="4617720" y="5715000"/>
+            <a:off x="4617720" y="5806440"/>
             <a:ext cx="7406640" cy="365760"/>
           </a:xfrm>
           <a:prstGeom prst="rect">
@@ -7157,7 +9849,7 @@
                 </a:solidFill>
                 <a:latin typeface="Segoe UI"/>
               </a:rPr>
-              <a:t>All 16 movement corridors overlaid on the frame.</a:t>
+              <a:t>The calibration editor: wizard right, layer toggles left.</a:t>
             </a:r>
           </a:p>
         </p:txBody>

</xml_diff>

<commit_message>
Auto-calibration sample window + parallel jobs — operator sets wall-clock start + duration (15 min..15 h, default +7 h/11 h = 07:00-18:00 on midnight-start files) resolved against the video's recording start; bounded pool (2) with FIFO queue and cancel-while-queued; honest progress with EMA-smoothed ETA; leave-the-page resilience (editor re-attaches, Cameras-tab jobs strip polls project-wide). 10 new tests, suite 967 green. Guide updated.
Co-Authored-By: Claude Fable 5 <noreply@anthropic.com>
</commit_message>
<xml_diff>
--- a/docs/Operator_Guide_2026-08-18.pptx
+++ b/docs/Operator_Guide_2026-08-18.pptx
@@ -7830,7 +7830,7 @@
                 </a:solidFill>
                 <a:latin typeface="Segoe UI"/>
               </a:rPr>
-              <a:t>•  Auto-calibration improves with busier video.</a:t>
+              <a:t>•  Auto-cal samples YOUR window — default 07:00–18:00. Pick the busy day, never midnight; jobs run in the background with an ETA.</a:t>
             </a:r>
           </a:p>
           <a:p>
@@ -9717,7 +9717,7 @@
                 </a:solidFill>
                 <a:latin typeface="Segoe UI"/>
               </a:rPr>
-              <a:t>Start from the proposal</a:t>
+              <a:t>Pick the window, then run</a:t>
             </a:r>
           </a:p>
           <a:p>
@@ -9733,7 +9733,7 @@
                 </a:solidFill>
                 <a:latin typeface="Segoe UI"/>
               </a:rPr>
-              <a:t>•  Auto-calibration watches real trajectories and proposes legs and road paths — Preview, then Apply or Reject.</a:t>
+              <a:t>•  Auto-calibration watches real traffic across YOUR sample window — set the wall-clock start and duration (15 min – 15 h) right in the panel.</a:t>
             </a:r>
           </a:p>
           <a:p>
@@ -9749,7 +9749,7 @@
                 </a:solidFill>
                 <a:latin typeface="Segoe UI"/>
               </a:rPr>
-              <a:t>•  Each leg is an approach mouth with its compass direction.</a:t>
+              <a:t>•  The default is the busy day: 07:00 for 11 h on a midnight-start file (+7 h into the footage otherwise) — prefilled for you.</a:t>
             </a:r>
           </a:p>
           <a:p>
@@ -9765,7 +9765,23 @@
                 </a:solidFill>
                 <a:latin typeface="Segoe UI"/>
               </a:rPr>
-              <a:t>•  Scrub to a busy moment before judging geometry.</a:t>
+              <a:t>•  Long windows are background jobs with a live % and time-left readout — leave the page freely; other cameras run in parallel (two at a time, the rest queue in order).</a:t>
+            </a:r>
+          </a:p>
+          <a:p>
+            <a:pPr algn="l">
+              <a:spcAft>
+                <a:spcPts val="700"/>
+              </a:spcAft>
+            </a:pPr>
+            <a:r>
+              <a:rPr sz="1350" b="0">
+                <a:solidFill>
+                  <a:srgbClr val="374151"/>
+                </a:solidFill>
+                <a:latin typeface="Segoe UI"/>
+              </a:rPr>
+              <a:t>•  When the proposal lands: Preview on canvas, then Apply or Reject.</a:t>
             </a:r>
           </a:p>
           <a:p>
@@ -9788,7 +9804,7 @@
       </p:sp>
       <p:pic>
         <p:nvPicPr>
-          <p:cNvPr id="4" name="Picture 3" descr="guide_06_calibration_editor.png"/>
+          <p:cNvPr id="4" name="Picture 3" descr="guide_13_autocal_controls.png"/>
           <p:cNvPicPr>
             <a:picLocks noChangeAspect="1"/>
           </p:cNvPicPr>
@@ -9803,7 +9819,7 @@
         <p:spPr>
           <a:xfrm>
             <a:off x="4617720" y="1481328"/>
-            <a:ext cx="7406640" cy="4166235"/>
+            <a:ext cx="7406640" cy="3429429"/>
           </a:xfrm>
           <a:prstGeom prst="rect">
             <a:avLst/>
@@ -9849,7 +9865,7 @@
                 </a:solidFill>
                 <a:latin typeface="Segoe UI"/>
               </a:rPr>
-              <a:t>The calibration editor: wizard right, layer toggles left.</a:t>
+              <a:t>The sample-window controls, prefilled with the 07:00–18:00 default.</a:t>
             </a:r>
           </a:p>
         </p:txBody>

</xml_diff>